<commit_message>
Update AVD Anywhere deck: single accent colour
Co-Authored-By: Claude Sonnet 5.5 <noreply@anthropic.com>
</commit_message>
<xml_diff>
--- a/presentation/AVD_Anywhere_NIC2026.pptx
+++ b/presentation/AVD_Anywhere_NIC2026.pptx
@@ -7648,17 +7648,17 @@
         <p:spPr>
           <a:xfrm>
             <a:off x="0" y="0"/>
-            <a:ext cx="1750815" cy="128016"/>
+            <a:ext cx="12191695" cy="128016"/>
           </a:xfrm>
           <a:prstGeom prst="rect">
             <a:avLst/>
           </a:prstGeom>
           <a:solidFill>
-            <a:srgbClr val="FF6B6B"/>
+            <a:srgbClr val="6CC3FF"/>
           </a:solidFill>
           <a:ln w="12700">
             <a:solidFill>
-              <a:srgbClr val="FF6B6B"/>
+              <a:srgbClr val="6CC3FF"/>
             </a:solidFill>
             <a:prstDash val="solid"/>
           </a:ln>
@@ -7672,18 +7672,18 @@
         </p:nvSpPr>
         <p:spPr>
           <a:xfrm>
-            <a:off x="1741671" y="0"/>
-            <a:ext cx="1750815" cy="128016"/>
+            <a:off x="0" y="6729984"/>
+            <a:ext cx="12191695" cy="128016"/>
           </a:xfrm>
           <a:prstGeom prst="rect">
             <a:avLst/>
           </a:prstGeom>
           <a:solidFill>
-            <a:srgbClr val="FFA94D"/>
+            <a:srgbClr val="6CC3FF"/>
           </a:solidFill>
           <a:ln w="12700">
             <a:solidFill>
-              <a:srgbClr val="FFA94D"/>
+              <a:srgbClr val="6CC3FF"/>
             </a:solidFill>
             <a:prstDash val="solid"/>
           </a:ln>
@@ -7691,307 +7691,7 @@
       </p:sp>
       <p:sp>
         <p:nvSpPr>
-          <p:cNvPr id="4" name="Shape 2"/>
-          <p:cNvSpPr/>
-          <p:nvPr/>
-        </p:nvSpPr>
-        <p:spPr>
-          <a:xfrm>
-            <a:off x="3483341" y="0"/>
-            <a:ext cx="1750815" cy="128016"/>
-          </a:xfrm>
-          <a:prstGeom prst="rect">
-            <a:avLst/>
-          </a:prstGeom>
-          <a:solidFill>
-            <a:srgbClr val="FFE066"/>
-          </a:solidFill>
-          <a:ln w="12700">
-            <a:solidFill>
-              <a:srgbClr val="FFE066"/>
-            </a:solidFill>
-            <a:prstDash val="solid"/>
-          </a:ln>
-        </p:spPr>
-      </p:sp>
-      <p:sp>
-        <p:nvSpPr>
-          <p:cNvPr id="5" name="Shape 3"/>
-          <p:cNvSpPr/>
-          <p:nvPr/>
-        </p:nvSpPr>
-        <p:spPr>
-          <a:xfrm>
-            <a:off x="5225012" y="0"/>
-            <a:ext cx="1750815" cy="128016"/>
-          </a:xfrm>
-          <a:prstGeom prst="rect">
-            <a:avLst/>
-          </a:prstGeom>
-          <a:solidFill>
-            <a:srgbClr val="8CE99A"/>
-          </a:solidFill>
-          <a:ln w="12700">
-            <a:solidFill>
-              <a:srgbClr val="8CE99A"/>
-            </a:solidFill>
-            <a:prstDash val="solid"/>
-          </a:ln>
-        </p:spPr>
-      </p:sp>
-      <p:sp>
-        <p:nvSpPr>
-          <p:cNvPr id="6" name="Shape 4"/>
-          <p:cNvSpPr/>
-          <p:nvPr/>
-        </p:nvSpPr>
-        <p:spPr>
-          <a:xfrm>
-            <a:off x="6966683" y="0"/>
-            <a:ext cx="1750815" cy="128016"/>
-          </a:xfrm>
-          <a:prstGeom prst="rect">
-            <a:avLst/>
-          </a:prstGeom>
-          <a:solidFill>
-            <a:srgbClr val="66D9E8"/>
-          </a:solidFill>
-          <a:ln w="12700">
-            <a:solidFill>
-              <a:srgbClr val="66D9E8"/>
-            </a:solidFill>
-            <a:prstDash val="solid"/>
-          </a:ln>
-        </p:spPr>
-      </p:sp>
-      <p:sp>
-        <p:nvSpPr>
-          <p:cNvPr id="7" name="Shape 5"/>
-          <p:cNvSpPr/>
-          <p:nvPr/>
-        </p:nvSpPr>
-        <p:spPr>
-          <a:xfrm>
-            <a:off x="8708354" y="0"/>
-            <a:ext cx="1750815" cy="128016"/>
-          </a:xfrm>
-          <a:prstGeom prst="rect">
-            <a:avLst/>
-          </a:prstGeom>
-          <a:solidFill>
-            <a:srgbClr val="74C0FC"/>
-          </a:solidFill>
-          <a:ln w="12700">
-            <a:solidFill>
-              <a:srgbClr val="74C0FC"/>
-            </a:solidFill>
-            <a:prstDash val="solid"/>
-          </a:ln>
-        </p:spPr>
-      </p:sp>
-      <p:sp>
-        <p:nvSpPr>
-          <p:cNvPr id="8" name="Shape 6"/>
-          <p:cNvSpPr/>
-          <p:nvPr/>
-        </p:nvSpPr>
-        <p:spPr>
-          <a:xfrm>
-            <a:off x="10450024" y="0"/>
-            <a:ext cx="1750815" cy="128016"/>
-          </a:xfrm>
-          <a:prstGeom prst="rect">
-            <a:avLst/>
-          </a:prstGeom>
-          <a:solidFill>
-            <a:srgbClr val="B197FC"/>
-          </a:solidFill>
-          <a:ln w="12700">
-            <a:solidFill>
-              <a:srgbClr val="B197FC"/>
-            </a:solidFill>
-            <a:prstDash val="solid"/>
-          </a:ln>
-        </p:spPr>
-      </p:sp>
-      <p:sp>
-        <p:nvSpPr>
-          <p:cNvPr id="9" name="Shape 7"/>
-          <p:cNvSpPr/>
-          <p:nvPr/>
-        </p:nvSpPr>
-        <p:spPr>
-          <a:xfrm>
-            <a:off x="0" y="6729984"/>
-            <a:ext cx="1750815" cy="128016"/>
-          </a:xfrm>
-          <a:prstGeom prst="rect">
-            <a:avLst/>
-          </a:prstGeom>
-          <a:solidFill>
-            <a:srgbClr val="FF6B6B"/>
-          </a:solidFill>
-          <a:ln w="12700">
-            <a:solidFill>
-              <a:srgbClr val="FF6B6B"/>
-            </a:solidFill>
-            <a:prstDash val="solid"/>
-          </a:ln>
-        </p:spPr>
-      </p:sp>
-      <p:sp>
-        <p:nvSpPr>
-          <p:cNvPr id="10" name="Shape 8"/>
-          <p:cNvSpPr/>
-          <p:nvPr/>
-        </p:nvSpPr>
-        <p:spPr>
-          <a:xfrm>
-            <a:off x="1741671" y="6729984"/>
-            <a:ext cx="1750815" cy="128016"/>
-          </a:xfrm>
-          <a:prstGeom prst="rect">
-            <a:avLst/>
-          </a:prstGeom>
-          <a:solidFill>
-            <a:srgbClr val="FFA94D"/>
-          </a:solidFill>
-          <a:ln w="12700">
-            <a:solidFill>
-              <a:srgbClr val="FFA94D"/>
-            </a:solidFill>
-            <a:prstDash val="solid"/>
-          </a:ln>
-        </p:spPr>
-      </p:sp>
-      <p:sp>
-        <p:nvSpPr>
-          <p:cNvPr id="11" name="Shape 9"/>
-          <p:cNvSpPr/>
-          <p:nvPr/>
-        </p:nvSpPr>
-        <p:spPr>
-          <a:xfrm>
-            <a:off x="3483341" y="6729984"/>
-            <a:ext cx="1750815" cy="128016"/>
-          </a:xfrm>
-          <a:prstGeom prst="rect">
-            <a:avLst/>
-          </a:prstGeom>
-          <a:solidFill>
-            <a:srgbClr val="FFE066"/>
-          </a:solidFill>
-          <a:ln w="12700">
-            <a:solidFill>
-              <a:srgbClr val="FFE066"/>
-            </a:solidFill>
-            <a:prstDash val="solid"/>
-          </a:ln>
-        </p:spPr>
-      </p:sp>
-      <p:sp>
-        <p:nvSpPr>
-          <p:cNvPr id="12" name="Shape 10"/>
-          <p:cNvSpPr/>
-          <p:nvPr/>
-        </p:nvSpPr>
-        <p:spPr>
-          <a:xfrm>
-            <a:off x="5225012" y="6729984"/>
-            <a:ext cx="1750815" cy="128016"/>
-          </a:xfrm>
-          <a:prstGeom prst="rect">
-            <a:avLst/>
-          </a:prstGeom>
-          <a:solidFill>
-            <a:srgbClr val="8CE99A"/>
-          </a:solidFill>
-          <a:ln w="12700">
-            <a:solidFill>
-              <a:srgbClr val="8CE99A"/>
-            </a:solidFill>
-            <a:prstDash val="solid"/>
-          </a:ln>
-        </p:spPr>
-      </p:sp>
-      <p:sp>
-        <p:nvSpPr>
-          <p:cNvPr id="13" name="Shape 11"/>
-          <p:cNvSpPr/>
-          <p:nvPr/>
-        </p:nvSpPr>
-        <p:spPr>
-          <a:xfrm>
-            <a:off x="6966683" y="6729984"/>
-            <a:ext cx="1750815" cy="128016"/>
-          </a:xfrm>
-          <a:prstGeom prst="rect">
-            <a:avLst/>
-          </a:prstGeom>
-          <a:solidFill>
-            <a:srgbClr val="66D9E8"/>
-          </a:solidFill>
-          <a:ln w="12700">
-            <a:solidFill>
-              <a:srgbClr val="66D9E8"/>
-            </a:solidFill>
-            <a:prstDash val="solid"/>
-          </a:ln>
-        </p:spPr>
-      </p:sp>
-      <p:sp>
-        <p:nvSpPr>
-          <p:cNvPr id="14" name="Shape 12"/>
-          <p:cNvSpPr/>
-          <p:nvPr/>
-        </p:nvSpPr>
-        <p:spPr>
-          <a:xfrm>
-            <a:off x="8708354" y="6729984"/>
-            <a:ext cx="1750815" cy="128016"/>
-          </a:xfrm>
-          <a:prstGeom prst="rect">
-            <a:avLst/>
-          </a:prstGeom>
-          <a:solidFill>
-            <a:srgbClr val="74C0FC"/>
-          </a:solidFill>
-          <a:ln w="12700">
-            <a:solidFill>
-              <a:srgbClr val="74C0FC"/>
-            </a:solidFill>
-            <a:prstDash val="solid"/>
-          </a:ln>
-        </p:spPr>
-      </p:sp>
-      <p:sp>
-        <p:nvSpPr>
-          <p:cNvPr id="15" name="Shape 13"/>
-          <p:cNvSpPr/>
-          <p:nvPr/>
-        </p:nvSpPr>
-        <p:spPr>
-          <a:xfrm>
-            <a:off x="10450024" y="6729984"/>
-            <a:ext cx="1750815" cy="128016"/>
-          </a:xfrm>
-          <a:prstGeom prst="rect">
-            <a:avLst/>
-          </a:prstGeom>
-          <a:solidFill>
-            <a:srgbClr val="B197FC"/>
-          </a:solidFill>
-          <a:ln w="12700">
-            <a:solidFill>
-              <a:srgbClr val="B197FC"/>
-            </a:solidFill>
-            <a:prstDash val="solid"/>
-          </a:ln>
-        </p:spPr>
-      </p:sp>
-      <p:sp>
-        <p:nvSpPr>
-          <p:cNvPr id="16" name="Text 14"/>
+          <p:cNvPr id="4" name="Text 2"/>
           <p:cNvSpPr/>
           <p:nvPr/>
         </p:nvSpPr>
@@ -8032,7 +7732,7 @@
       </p:sp>
       <p:sp>
         <p:nvSpPr>
-          <p:cNvPr id="17" name="Text 15"/>
+          <p:cNvPr id="5" name="Text 3"/>
           <p:cNvSpPr/>
           <p:nvPr/>
         </p:nvSpPr>
@@ -9454,26 +9154,67 @@
       </p:sp>
       <p:sp>
         <p:nvSpPr>
-          <p:cNvPr id="4" name="Shape 2"/>
-          <p:cNvSpPr/>
-          <p:nvPr/>
-        </p:nvSpPr>
-        <p:spPr>
-          <a:xfrm>
-            <a:off x="822960" y="1554480"/>
-            <a:ext cx="3322320" cy="1965960"/>
+          <p:cNvPr id="4" name="Text 2"/>
+          <p:cNvSpPr/>
+          <p:nvPr/>
+        </p:nvSpPr>
+        <p:spPr>
+          <a:xfrm>
+            <a:off x="548640" y="1188720"/>
+            <a:ext cx="11064240" cy="548640"/>
+          </a:xfrm>
+          <a:prstGeom prst="rect">
+            <a:avLst/>
+          </a:prstGeom>
+          <a:noFill/>
+          <a:ln/>
+        </p:spPr>
+        <p:txBody>
+          <a:bodyPr wrap="square" rtlCol="0" anchor="t">
+            <a:normAutofit/>
+          </a:bodyPr>
+          <a:lstStyle/>
+          <a:p>
+            <a:pPr indent="0" marL="0">
+              <a:buNone/>
+            </a:pPr>
+            <a:r>
+              <a:rPr lang="en-US" sz="2000" i="1" dirty="0">
+                <a:solidFill>
+                  <a:srgbClr val="6CC3FF"/>
+                </a:solidFill>
+                <a:latin typeface="Roboto" pitchFamily="34" charset="0"/>
+                <a:ea typeface="Roboto" pitchFamily="34" charset="-122"/>
+                <a:cs typeface="Roboto" pitchFamily="34" charset="-120"/>
+              </a:rPr>
+              <a:t>Before any realm: the bridge they share.</a:t>
+            </a:r>
+            <a:endParaRPr lang="en-US" sz="2000" dirty="0"/>
+          </a:p>
+        </p:txBody>
+      </p:sp>
+      <p:sp>
+        <p:nvSpPr>
+          <p:cNvPr id="5" name="Shape 3"/>
+          <p:cNvSpPr/>
+          <p:nvPr/>
+        </p:nvSpPr>
+        <p:spPr>
+          <a:xfrm>
+            <a:off x="548640" y="1920240"/>
+            <a:ext cx="11064240" cy="4297680"/>
           </a:xfrm>
           <a:prstGeom prst="roundRect">
             <a:avLst>
-              <a:gd name="adj" fmla="val 3721"/>
+              <a:gd name="adj" fmla="val 1702"/>
             </a:avLst>
           </a:prstGeom>
           <a:solidFill>
             <a:srgbClr val="182034"/>
           </a:solidFill>
-          <a:ln w="25400">
+          <a:ln w="12700">
             <a:solidFill>
-              <a:srgbClr val="6CC3FF"/>
+              <a:srgbClr val="33406A"/>
             </a:solidFill>
             <a:prstDash val="solid"/>
           </a:ln>
@@ -9481,536 +9222,36 @@
       </p:sp>
       <p:sp>
         <p:nvSpPr>
-          <p:cNvPr id="5" name="Text 3"/>
-          <p:cNvSpPr/>
-          <p:nvPr/>
-        </p:nvSpPr>
-        <p:spPr>
-          <a:xfrm>
-            <a:off x="822960" y="1691640"/>
-            <a:ext cx="3322320" cy="548640"/>
-          </a:xfrm>
-          <a:prstGeom prst="rect">
-            <a:avLst/>
-          </a:prstGeom>
-          <a:noFill/>
-          <a:ln/>
-        </p:spPr>
-        <p:txBody>
-          <a:bodyPr wrap="square" rtlCol="0" anchor="ctr"/>
-          <a:lstStyle/>
-          <a:p>
-            <a:pPr algn="ctr" indent="0" marL="0">
-              <a:buNone/>
-            </a:pPr>
-            <a:r>
-              <a:rPr lang="en-US" sz="2200" b="1" dirty="0">
-                <a:solidFill>
-                  <a:srgbClr val="6CC3FF"/>
-                </a:solidFill>
-                <a:latin typeface="Roboto" pitchFamily="34" charset="0"/>
-                <a:ea typeface="Roboto" pitchFamily="34" charset="-122"/>
-                <a:cs typeface="Roboto" pitchFamily="34" charset="-120"/>
-              </a:rPr>
-              <a:t>Azure</a:t>
-            </a:r>
-            <a:endParaRPr lang="en-US" sz="2200" dirty="0"/>
-          </a:p>
-        </p:txBody>
-      </p:sp>
-      <p:sp>
-        <p:nvSpPr>
           <p:cNvPr id="6" name="Text 4"/>
           <p:cNvSpPr/>
           <p:nvPr/>
         </p:nvSpPr>
         <p:spPr>
           <a:xfrm>
-            <a:off x="960120" y="2286000"/>
-            <a:ext cx="3048000" cy="1097280"/>
-          </a:xfrm>
-          <a:prstGeom prst="rect">
-            <a:avLst/>
-          </a:prstGeom>
-          <a:noFill/>
-          <a:ln/>
-        </p:spPr>
-        <p:txBody>
-          <a:bodyPr wrap="square" rtlCol="0" anchor="t"/>
-          <a:lstStyle/>
-          <a:p>
-            <a:pPr algn="ctr" indent="0" marL="0">
-              <a:buNone/>
-            </a:pPr>
-            <a:r>
-              <a:rPr lang="en-US" sz="1400" dirty="0">
-                <a:solidFill>
-                  <a:srgbClr val="E9EEF7"/>
-                </a:solidFill>
-                <a:latin typeface="Roboto" pitchFamily="34" charset="0"/>
-                <a:ea typeface="Roboto" pitchFamily="34" charset="-122"/>
-                <a:cs typeface="Roboto" pitchFamily="34" charset="-120"/>
-              </a:rPr>
-              <a:t>Elastic, pooled, Entra-joined</a:t>
-            </a:r>
-            <a:endParaRPr lang="en-US" sz="1400" dirty="0"/>
-          </a:p>
-        </p:txBody>
-      </p:sp>
-      <p:sp>
-        <p:nvSpPr>
-          <p:cNvPr id="7" name="Shape 5"/>
-          <p:cNvSpPr/>
-          <p:nvPr/>
-        </p:nvSpPr>
-        <p:spPr>
-          <a:xfrm>
-            <a:off x="4419600" y="1554480"/>
-            <a:ext cx="3322320" cy="1965960"/>
-          </a:xfrm>
-          <a:prstGeom prst="roundRect">
-            <a:avLst>
-              <a:gd name="adj" fmla="val 3721"/>
-            </a:avLst>
-          </a:prstGeom>
-          <a:solidFill>
-            <a:srgbClr val="182034"/>
-          </a:solidFill>
-          <a:ln w="25400">
-            <a:solidFill>
-              <a:srgbClr val="7BD88F"/>
-            </a:solidFill>
-            <a:prstDash val="solid"/>
-          </a:ln>
-        </p:spPr>
-      </p:sp>
-      <p:sp>
-        <p:nvSpPr>
-          <p:cNvPr id="8" name="Text 6"/>
-          <p:cNvSpPr/>
-          <p:nvPr/>
-        </p:nvSpPr>
-        <p:spPr>
-          <a:xfrm>
-            <a:off x="4419600" y="1691640"/>
-            <a:ext cx="3322320" cy="548640"/>
-          </a:xfrm>
-          <a:prstGeom prst="rect">
-            <a:avLst/>
-          </a:prstGeom>
-          <a:noFill/>
-          <a:ln/>
-        </p:spPr>
-        <p:txBody>
-          <a:bodyPr wrap="square" rtlCol="0" anchor="ctr"/>
-          <a:lstStyle/>
-          <a:p>
-            <a:pPr algn="ctr" indent="0" marL="0">
-              <a:buNone/>
-            </a:pPr>
-            <a:r>
-              <a:rPr lang="en-US" sz="2200" b="1" dirty="0">
-                <a:solidFill>
-                  <a:srgbClr val="7BD88F"/>
-                </a:solidFill>
-                <a:latin typeface="Roboto" pitchFamily="34" charset="0"/>
-                <a:ea typeface="Roboto" pitchFamily="34" charset="-122"/>
-                <a:cs typeface="Roboto" pitchFamily="34" charset="-120"/>
-              </a:rPr>
-              <a:t>Azure Local</a:t>
-            </a:r>
-            <a:endParaRPr lang="en-US" sz="2200" dirty="0"/>
-          </a:p>
-        </p:txBody>
-      </p:sp>
-      <p:sp>
-        <p:nvSpPr>
-          <p:cNvPr id="9" name="Text 7"/>
-          <p:cNvSpPr/>
-          <p:nvPr/>
-        </p:nvSpPr>
-        <p:spPr>
-          <a:xfrm>
-            <a:off x="4556760" y="2286000"/>
-            <a:ext cx="3048000" cy="1097280"/>
-          </a:xfrm>
-          <a:prstGeom prst="rect">
-            <a:avLst/>
-          </a:prstGeom>
-          <a:noFill/>
-          <a:ln/>
-        </p:spPr>
-        <p:txBody>
-          <a:bodyPr wrap="square" rtlCol="0" anchor="t"/>
-          <a:lstStyle/>
-          <a:p>
-            <a:pPr algn="ctr" indent="0" marL="0">
-              <a:buNone/>
-            </a:pPr>
-            <a:r>
-              <a:rPr lang="en-US" sz="1400" dirty="0">
-                <a:solidFill>
-                  <a:srgbClr val="E9EEF7"/>
-                </a:solidFill>
-                <a:latin typeface="Roboto" pitchFamily="34" charset="0"/>
-                <a:ea typeface="Roboto" pitchFamily="34" charset="-122"/>
-                <a:cs typeface="Roboto" pitchFamily="34" charset="-120"/>
-              </a:rPr>
-              <a:t>Your site: data, latency, regulation</a:t>
-            </a:r>
-            <a:endParaRPr lang="en-US" sz="1400" dirty="0"/>
-          </a:p>
-        </p:txBody>
-      </p:sp>
-      <p:sp>
-        <p:nvSpPr>
-          <p:cNvPr id="10" name="Shape 8"/>
-          <p:cNvSpPr/>
-          <p:nvPr/>
-        </p:nvSpPr>
-        <p:spPr>
-          <a:xfrm>
-            <a:off x="8016240" y="1554480"/>
-            <a:ext cx="3322320" cy="1965960"/>
-          </a:xfrm>
-          <a:prstGeom prst="roundRect">
-            <a:avLst>
-              <a:gd name="adj" fmla="val 3721"/>
-            </a:avLst>
-          </a:prstGeom>
-          <a:solidFill>
-            <a:srgbClr val="182034"/>
-          </a:solidFill>
-          <a:ln w="25400">
-            <a:solidFill>
-              <a:srgbClr val="F5B84B"/>
-            </a:solidFill>
-            <a:prstDash val="solid"/>
-          </a:ln>
-        </p:spPr>
-      </p:sp>
-      <p:sp>
-        <p:nvSpPr>
-          <p:cNvPr id="11" name="Text 9"/>
-          <p:cNvSpPr/>
-          <p:nvPr/>
-        </p:nvSpPr>
-        <p:spPr>
-          <a:xfrm>
-            <a:off x="8016240" y="1691640"/>
-            <a:ext cx="3322320" cy="548640"/>
-          </a:xfrm>
-          <a:prstGeom prst="rect">
-            <a:avLst/>
-          </a:prstGeom>
-          <a:noFill/>
-          <a:ln/>
-        </p:spPr>
-        <p:txBody>
-          <a:bodyPr wrap="square" rtlCol="0" anchor="ctr"/>
-          <a:lstStyle/>
-          <a:p>
-            <a:pPr algn="ctr" indent="0" marL="0">
-              <a:buNone/>
-            </a:pPr>
-            <a:r>
-              <a:rPr lang="en-US" sz="2200" b="1" dirty="0">
-                <a:solidFill>
-                  <a:srgbClr val="F5B84B"/>
-                </a:solidFill>
-                <a:latin typeface="Roboto" pitchFamily="34" charset="0"/>
-                <a:ea typeface="Roboto" pitchFamily="34" charset="-122"/>
-                <a:cs typeface="Roboto" pitchFamily="34" charset="-120"/>
-              </a:rPr>
-              <a:t>AVD Hybrid</a:t>
-            </a:r>
-            <a:endParaRPr lang="en-US" sz="2200" dirty="0"/>
-          </a:p>
-        </p:txBody>
-      </p:sp>
-      <p:sp>
-        <p:nvSpPr>
-          <p:cNvPr id="12" name="Text 10"/>
-          <p:cNvSpPr/>
-          <p:nvPr/>
-        </p:nvSpPr>
-        <p:spPr>
-          <a:xfrm>
-            <a:off x="8153400" y="2286000"/>
-            <a:ext cx="3048000" cy="1097280"/>
-          </a:xfrm>
-          <a:prstGeom prst="rect">
-            <a:avLst/>
-          </a:prstGeom>
-          <a:noFill/>
-          <a:ln/>
-        </p:spPr>
-        <p:txBody>
-          <a:bodyPr wrap="square" rtlCol="0" anchor="t"/>
-          <a:lstStyle/>
-          <a:p>
-            <a:pPr algn="ctr" indent="0" marL="0">
-              <a:buNone/>
-            </a:pPr>
-            <a:r>
-              <a:rPr lang="en-US" sz="1400" dirty="0">
-                <a:solidFill>
-                  <a:srgbClr val="E9EEF7"/>
-                </a:solidFill>
-                <a:latin typeface="Roboto" pitchFamily="34" charset="0"/>
-                <a:ea typeface="Roboto" pitchFamily="34" charset="-122"/>
-                <a:cs typeface="Roboto" pitchFamily="34" charset="-120"/>
-              </a:rPr>
-              <a:t>Your hypervisor, Arc-enabled VMs</a:t>
-            </a:r>
-            <a:endParaRPr lang="en-US" sz="1400" dirty="0"/>
-          </a:p>
-        </p:txBody>
-      </p:sp>
-      <p:sp>
-        <p:nvSpPr>
-          <p:cNvPr id="13" name="Shape 11"/>
-          <p:cNvSpPr/>
-          <p:nvPr/>
-        </p:nvSpPr>
-        <p:spPr>
-          <a:xfrm>
-            <a:off x="822960" y="3703320"/>
-            <a:ext cx="1502229" cy="164592"/>
-          </a:xfrm>
-          <a:prstGeom prst="rect">
-            <a:avLst/>
-          </a:prstGeom>
-          <a:solidFill>
-            <a:srgbClr val="FF6B6B"/>
-          </a:solidFill>
-          <a:ln w="12700">
-            <a:solidFill>
-              <a:srgbClr val="FF6B6B"/>
-            </a:solidFill>
-            <a:prstDash val="solid"/>
-          </a:ln>
-        </p:spPr>
-      </p:sp>
-      <p:sp>
-        <p:nvSpPr>
-          <p:cNvPr id="14" name="Shape 12"/>
-          <p:cNvSpPr/>
-          <p:nvPr/>
-        </p:nvSpPr>
-        <p:spPr>
-          <a:xfrm>
-            <a:off x="2325189" y="3703320"/>
-            <a:ext cx="1502229" cy="164592"/>
-          </a:xfrm>
-          <a:prstGeom prst="rect">
-            <a:avLst/>
-          </a:prstGeom>
-          <a:solidFill>
-            <a:srgbClr val="FFA94D"/>
-          </a:solidFill>
-          <a:ln w="12700">
-            <a:solidFill>
-              <a:srgbClr val="FFA94D"/>
-            </a:solidFill>
-            <a:prstDash val="solid"/>
-          </a:ln>
-        </p:spPr>
-      </p:sp>
-      <p:sp>
-        <p:nvSpPr>
-          <p:cNvPr id="15" name="Shape 13"/>
-          <p:cNvSpPr/>
-          <p:nvPr/>
-        </p:nvSpPr>
-        <p:spPr>
-          <a:xfrm>
-            <a:off x="3827417" y="3703320"/>
-            <a:ext cx="1502229" cy="164592"/>
-          </a:xfrm>
-          <a:prstGeom prst="rect">
-            <a:avLst/>
-          </a:prstGeom>
-          <a:solidFill>
-            <a:srgbClr val="FFE066"/>
-          </a:solidFill>
-          <a:ln w="12700">
-            <a:solidFill>
-              <a:srgbClr val="FFE066"/>
-            </a:solidFill>
-            <a:prstDash val="solid"/>
-          </a:ln>
-        </p:spPr>
-      </p:sp>
-      <p:sp>
-        <p:nvSpPr>
-          <p:cNvPr id="16" name="Shape 14"/>
-          <p:cNvSpPr/>
-          <p:nvPr/>
-        </p:nvSpPr>
-        <p:spPr>
-          <a:xfrm>
-            <a:off x="5329646" y="3703320"/>
-            <a:ext cx="1502229" cy="164592"/>
-          </a:xfrm>
-          <a:prstGeom prst="rect">
-            <a:avLst/>
-          </a:prstGeom>
-          <a:solidFill>
-            <a:srgbClr val="8CE99A"/>
-          </a:solidFill>
-          <a:ln w="12700">
-            <a:solidFill>
-              <a:srgbClr val="8CE99A"/>
-            </a:solidFill>
-            <a:prstDash val="solid"/>
-          </a:ln>
-        </p:spPr>
-      </p:sp>
-      <p:sp>
-        <p:nvSpPr>
-          <p:cNvPr id="17" name="Shape 15"/>
-          <p:cNvSpPr/>
-          <p:nvPr/>
-        </p:nvSpPr>
-        <p:spPr>
-          <a:xfrm>
-            <a:off x="6831874" y="3703320"/>
-            <a:ext cx="1502229" cy="164592"/>
-          </a:xfrm>
-          <a:prstGeom prst="rect">
-            <a:avLst/>
-          </a:prstGeom>
-          <a:solidFill>
-            <a:srgbClr val="66D9E8"/>
-          </a:solidFill>
-          <a:ln w="12700">
-            <a:solidFill>
-              <a:srgbClr val="66D9E8"/>
-            </a:solidFill>
-            <a:prstDash val="solid"/>
-          </a:ln>
-        </p:spPr>
-      </p:sp>
-      <p:sp>
-        <p:nvSpPr>
-          <p:cNvPr id="18" name="Shape 16"/>
-          <p:cNvSpPr/>
-          <p:nvPr/>
-        </p:nvSpPr>
-        <p:spPr>
-          <a:xfrm>
-            <a:off x="8334103" y="3703320"/>
-            <a:ext cx="1502229" cy="164592"/>
-          </a:xfrm>
-          <a:prstGeom prst="rect">
-            <a:avLst/>
-          </a:prstGeom>
-          <a:solidFill>
-            <a:srgbClr val="74C0FC"/>
-          </a:solidFill>
-          <a:ln w="12700">
-            <a:solidFill>
-              <a:srgbClr val="74C0FC"/>
-            </a:solidFill>
-            <a:prstDash val="solid"/>
-          </a:ln>
-        </p:spPr>
-      </p:sp>
-      <p:sp>
-        <p:nvSpPr>
-          <p:cNvPr id="19" name="Shape 17"/>
-          <p:cNvSpPr/>
-          <p:nvPr/>
-        </p:nvSpPr>
-        <p:spPr>
-          <a:xfrm>
-            <a:off x="9836331" y="3703320"/>
-            <a:ext cx="1502229" cy="164592"/>
-          </a:xfrm>
-          <a:prstGeom prst="rect">
-            <a:avLst/>
-          </a:prstGeom>
-          <a:solidFill>
-            <a:srgbClr val="B197FC"/>
-          </a:solidFill>
-          <a:ln w="12700">
-            <a:solidFill>
-              <a:srgbClr val="B197FC"/>
-            </a:solidFill>
-            <a:prstDash val="solid"/>
-          </a:ln>
-        </p:spPr>
-      </p:sp>
-      <p:sp>
-        <p:nvSpPr>
-          <p:cNvPr id="20" name="Text 18"/>
-          <p:cNvSpPr/>
-          <p:nvPr/>
-        </p:nvSpPr>
-        <p:spPr>
-          <a:xfrm>
-            <a:off x="822960" y="3904488"/>
-            <a:ext cx="10515600" cy="457200"/>
-          </a:xfrm>
-          <a:prstGeom prst="rect">
-            <a:avLst/>
-          </a:prstGeom>
-          <a:noFill/>
-          <a:ln/>
-        </p:spPr>
-        <p:txBody>
-          <a:bodyPr wrap="square" rtlCol="0" anchor="ctr"/>
-          <a:lstStyle/>
-          <a:p>
-            <a:pPr algn="ctr" indent="0" marL="0">
-              <a:buNone/>
-            </a:pPr>
-            <a:r>
-              <a:rPr lang="en-US" sz="1800" b="1" dirty="0">
-                <a:solidFill>
-                  <a:srgbClr val="E9EEF7"/>
-                </a:solidFill>
-                <a:latin typeface="Roboto" pitchFamily="34" charset="0"/>
-                <a:ea typeface="Roboto" pitchFamily="34" charset="-122"/>
-                <a:cs typeface="Roboto" pitchFamily="34" charset="-120"/>
-              </a:rPr>
-              <a:t>Entra ID + Arc</a:t>
-            </a:r>
-            <a:endParaRPr lang="en-US" sz="1800" dirty="0"/>
-          </a:p>
-        </p:txBody>
-      </p:sp>
-      <p:sp>
-        <p:nvSpPr>
-          <p:cNvPr id="21" name="Text 19"/>
-          <p:cNvSpPr/>
-          <p:nvPr/>
-        </p:nvSpPr>
-        <p:spPr>
-          <a:xfrm>
-            <a:off x="822960" y="4800600"/>
-            <a:ext cx="10515600" cy="1554480"/>
-          </a:xfrm>
-          <a:prstGeom prst="rect">
-            <a:avLst/>
-          </a:prstGeom>
-          <a:noFill/>
-          <a:ln/>
-        </p:spPr>
-        <p:txBody>
-          <a:bodyPr wrap="square" rtlCol="0" anchor="t"/>
+            <a:off x="868680" y="2103120"/>
+            <a:ext cx="10424160" cy="3931920"/>
+          </a:xfrm>
+          <a:prstGeom prst="rect">
+            <a:avLst/>
+          </a:prstGeom>
+          <a:noFill/>
+          <a:ln/>
+        </p:spPr>
+        <p:txBody>
+          <a:bodyPr wrap="square" rtlCol="0" anchor="t">
+            <a:normAutofit/>
+          </a:bodyPr>
           <a:lstStyle/>
           <a:p>
             <a:pPr marL="342900" indent="-342900">
               <a:spcAft>
-                <a:spcPts val="600"/>
+                <a:spcPts val="1200"/>
               </a:spcAft>
               <a:buSzPct val="100000"/>
               <a:buChar char="•"/>
             </a:pPr>
             <a:r>
-              <a:rPr lang="en-US" sz="1800" dirty="0">
+              <a:rPr lang="en-US" sz="2200" dirty="0">
                 <a:solidFill>
                   <a:srgbClr val="E9EEF7"/>
                 </a:solidFill>
@@ -10020,13 +9261,13 @@
               </a:rPr>
               <a:t>Next: one identity, three paths</a:t>
             </a:r>
-            <a:endParaRPr lang="en-US" sz="1800" dirty="0"/>
-          </a:p>
-        </p:txBody>
-      </p:sp>
-      <p:sp>
-        <p:nvSpPr>
-          <p:cNvPr id="22" name="Text 20"/>
+            <a:endParaRPr lang="en-US" sz="2200" dirty="0"/>
+          </a:p>
+        </p:txBody>
+      </p:sp>
+      <p:sp>
+        <p:nvSpPr>
+          <p:cNvPr id="7" name="Text 5"/>
           <p:cNvSpPr/>
           <p:nvPr/>
         </p:nvSpPr>
@@ -10065,7 +9306,7 @@
       </p:sp>
       <p:sp>
         <p:nvSpPr>
-          <p:cNvPr id="23" name="Text 21"/>
+          <p:cNvPr id="8" name="Text 6"/>
           <p:cNvSpPr/>
           <p:nvPr/>
         </p:nvSpPr>
@@ -10143,17 +9384,17 @@
         <p:spPr>
           <a:xfrm>
             <a:off x="0" y="0"/>
-            <a:ext cx="1750815" cy="128016"/>
+            <a:ext cx="12191695" cy="128016"/>
           </a:xfrm>
           <a:prstGeom prst="rect">
             <a:avLst/>
           </a:prstGeom>
           <a:solidFill>
-            <a:srgbClr val="FF6B6B"/>
+            <a:srgbClr val="6CC3FF"/>
           </a:solidFill>
           <a:ln w="12700">
             <a:solidFill>
-              <a:srgbClr val="FF6B6B"/>
+              <a:srgbClr val="6CC3FF"/>
             </a:solidFill>
             <a:prstDash val="solid"/>
           </a:ln>
@@ -10161,157 +9402,7 @@
       </p:sp>
       <p:sp>
         <p:nvSpPr>
-          <p:cNvPr id="3" name="Shape 1"/>
-          <p:cNvSpPr/>
-          <p:nvPr/>
-        </p:nvSpPr>
-        <p:spPr>
-          <a:xfrm>
-            <a:off x="1741671" y="0"/>
-            <a:ext cx="1750815" cy="128016"/>
-          </a:xfrm>
-          <a:prstGeom prst="rect">
-            <a:avLst/>
-          </a:prstGeom>
-          <a:solidFill>
-            <a:srgbClr val="FFA94D"/>
-          </a:solidFill>
-          <a:ln w="12700">
-            <a:solidFill>
-              <a:srgbClr val="FFA94D"/>
-            </a:solidFill>
-            <a:prstDash val="solid"/>
-          </a:ln>
-        </p:spPr>
-      </p:sp>
-      <p:sp>
-        <p:nvSpPr>
-          <p:cNvPr id="4" name="Shape 2"/>
-          <p:cNvSpPr/>
-          <p:nvPr/>
-        </p:nvSpPr>
-        <p:spPr>
-          <a:xfrm>
-            <a:off x="3483341" y="0"/>
-            <a:ext cx="1750815" cy="128016"/>
-          </a:xfrm>
-          <a:prstGeom prst="rect">
-            <a:avLst/>
-          </a:prstGeom>
-          <a:solidFill>
-            <a:srgbClr val="FFE066"/>
-          </a:solidFill>
-          <a:ln w="12700">
-            <a:solidFill>
-              <a:srgbClr val="FFE066"/>
-            </a:solidFill>
-            <a:prstDash val="solid"/>
-          </a:ln>
-        </p:spPr>
-      </p:sp>
-      <p:sp>
-        <p:nvSpPr>
-          <p:cNvPr id="5" name="Shape 3"/>
-          <p:cNvSpPr/>
-          <p:nvPr/>
-        </p:nvSpPr>
-        <p:spPr>
-          <a:xfrm>
-            <a:off x="5225012" y="0"/>
-            <a:ext cx="1750815" cy="128016"/>
-          </a:xfrm>
-          <a:prstGeom prst="rect">
-            <a:avLst/>
-          </a:prstGeom>
-          <a:solidFill>
-            <a:srgbClr val="8CE99A"/>
-          </a:solidFill>
-          <a:ln w="12700">
-            <a:solidFill>
-              <a:srgbClr val="8CE99A"/>
-            </a:solidFill>
-            <a:prstDash val="solid"/>
-          </a:ln>
-        </p:spPr>
-      </p:sp>
-      <p:sp>
-        <p:nvSpPr>
-          <p:cNvPr id="6" name="Shape 4"/>
-          <p:cNvSpPr/>
-          <p:nvPr/>
-        </p:nvSpPr>
-        <p:spPr>
-          <a:xfrm>
-            <a:off x="6966683" y="0"/>
-            <a:ext cx="1750815" cy="128016"/>
-          </a:xfrm>
-          <a:prstGeom prst="rect">
-            <a:avLst/>
-          </a:prstGeom>
-          <a:solidFill>
-            <a:srgbClr val="66D9E8"/>
-          </a:solidFill>
-          <a:ln w="12700">
-            <a:solidFill>
-              <a:srgbClr val="66D9E8"/>
-            </a:solidFill>
-            <a:prstDash val="solid"/>
-          </a:ln>
-        </p:spPr>
-      </p:sp>
-      <p:sp>
-        <p:nvSpPr>
-          <p:cNvPr id="7" name="Shape 5"/>
-          <p:cNvSpPr/>
-          <p:nvPr/>
-        </p:nvSpPr>
-        <p:spPr>
-          <a:xfrm>
-            <a:off x="8708354" y="0"/>
-            <a:ext cx="1750815" cy="128016"/>
-          </a:xfrm>
-          <a:prstGeom prst="rect">
-            <a:avLst/>
-          </a:prstGeom>
-          <a:solidFill>
-            <a:srgbClr val="74C0FC"/>
-          </a:solidFill>
-          <a:ln w="12700">
-            <a:solidFill>
-              <a:srgbClr val="74C0FC"/>
-            </a:solidFill>
-            <a:prstDash val="solid"/>
-          </a:ln>
-        </p:spPr>
-      </p:sp>
-      <p:sp>
-        <p:nvSpPr>
-          <p:cNvPr id="8" name="Shape 6"/>
-          <p:cNvSpPr/>
-          <p:nvPr/>
-        </p:nvSpPr>
-        <p:spPr>
-          <a:xfrm>
-            <a:off x="10450024" y="0"/>
-            <a:ext cx="1750815" cy="128016"/>
-          </a:xfrm>
-          <a:prstGeom prst="rect">
-            <a:avLst/>
-          </a:prstGeom>
-          <a:solidFill>
-            <a:srgbClr val="B197FC"/>
-          </a:solidFill>
-          <a:ln w="12700">
-            <a:solidFill>
-              <a:srgbClr val="B197FC"/>
-            </a:solidFill>
-            <a:prstDash val="solid"/>
-          </a:ln>
-        </p:spPr>
-      </p:sp>
-      <p:sp>
-        <p:nvSpPr>
-          <p:cNvPr id="9" name="Text 7"/>
+          <p:cNvPr id="3" name="Text 1"/>
           <p:cNvSpPr/>
           <p:nvPr/>
         </p:nvSpPr>
@@ -10350,7 +9441,7 @@
       </p:sp>
       <p:sp>
         <p:nvSpPr>
-          <p:cNvPr id="10" name="Text 8"/>
+          <p:cNvPr id="4" name="Text 2"/>
           <p:cNvSpPr/>
           <p:nvPr/>
         </p:nvSpPr>
@@ -10391,7 +9482,7 @@
       </p:sp>
       <p:sp>
         <p:nvSpPr>
-          <p:cNvPr id="11" name="Text 9"/>
+          <p:cNvPr id="5" name="Text 3"/>
           <p:cNvSpPr/>
           <p:nvPr/>
         </p:nvSpPr>
@@ -13589,17 +12680,17 @@
         <p:spPr>
           <a:xfrm>
             <a:off x="0" y="0"/>
-            <a:ext cx="1750815" cy="128016"/>
+            <a:ext cx="12191695" cy="128016"/>
           </a:xfrm>
           <a:prstGeom prst="rect">
             <a:avLst/>
           </a:prstGeom>
           <a:solidFill>
-            <a:srgbClr val="FF6B6B"/>
+            <a:srgbClr val="6CC3FF"/>
           </a:solidFill>
           <a:ln w="12700">
             <a:solidFill>
-              <a:srgbClr val="FF6B6B"/>
+              <a:srgbClr val="6CC3FF"/>
             </a:solidFill>
             <a:prstDash val="solid"/>
           </a:ln>
@@ -13607,157 +12698,7 @@
       </p:sp>
       <p:sp>
         <p:nvSpPr>
-          <p:cNvPr id="3" name="Shape 1"/>
-          <p:cNvSpPr/>
-          <p:nvPr/>
-        </p:nvSpPr>
-        <p:spPr>
-          <a:xfrm>
-            <a:off x="1741671" y="0"/>
-            <a:ext cx="1750815" cy="128016"/>
-          </a:xfrm>
-          <a:prstGeom prst="rect">
-            <a:avLst/>
-          </a:prstGeom>
-          <a:solidFill>
-            <a:srgbClr val="FFA94D"/>
-          </a:solidFill>
-          <a:ln w="12700">
-            <a:solidFill>
-              <a:srgbClr val="FFA94D"/>
-            </a:solidFill>
-            <a:prstDash val="solid"/>
-          </a:ln>
-        </p:spPr>
-      </p:sp>
-      <p:sp>
-        <p:nvSpPr>
-          <p:cNvPr id="4" name="Shape 2"/>
-          <p:cNvSpPr/>
-          <p:nvPr/>
-        </p:nvSpPr>
-        <p:spPr>
-          <a:xfrm>
-            <a:off x="3483341" y="0"/>
-            <a:ext cx="1750815" cy="128016"/>
-          </a:xfrm>
-          <a:prstGeom prst="rect">
-            <a:avLst/>
-          </a:prstGeom>
-          <a:solidFill>
-            <a:srgbClr val="FFE066"/>
-          </a:solidFill>
-          <a:ln w="12700">
-            <a:solidFill>
-              <a:srgbClr val="FFE066"/>
-            </a:solidFill>
-            <a:prstDash val="solid"/>
-          </a:ln>
-        </p:spPr>
-      </p:sp>
-      <p:sp>
-        <p:nvSpPr>
-          <p:cNvPr id="5" name="Shape 3"/>
-          <p:cNvSpPr/>
-          <p:nvPr/>
-        </p:nvSpPr>
-        <p:spPr>
-          <a:xfrm>
-            <a:off x="5225012" y="0"/>
-            <a:ext cx="1750815" cy="128016"/>
-          </a:xfrm>
-          <a:prstGeom prst="rect">
-            <a:avLst/>
-          </a:prstGeom>
-          <a:solidFill>
-            <a:srgbClr val="8CE99A"/>
-          </a:solidFill>
-          <a:ln w="12700">
-            <a:solidFill>
-              <a:srgbClr val="8CE99A"/>
-            </a:solidFill>
-            <a:prstDash val="solid"/>
-          </a:ln>
-        </p:spPr>
-      </p:sp>
-      <p:sp>
-        <p:nvSpPr>
-          <p:cNvPr id="6" name="Shape 4"/>
-          <p:cNvSpPr/>
-          <p:nvPr/>
-        </p:nvSpPr>
-        <p:spPr>
-          <a:xfrm>
-            <a:off x="6966683" y="0"/>
-            <a:ext cx="1750815" cy="128016"/>
-          </a:xfrm>
-          <a:prstGeom prst="rect">
-            <a:avLst/>
-          </a:prstGeom>
-          <a:solidFill>
-            <a:srgbClr val="66D9E8"/>
-          </a:solidFill>
-          <a:ln w="12700">
-            <a:solidFill>
-              <a:srgbClr val="66D9E8"/>
-            </a:solidFill>
-            <a:prstDash val="solid"/>
-          </a:ln>
-        </p:spPr>
-      </p:sp>
-      <p:sp>
-        <p:nvSpPr>
-          <p:cNvPr id="7" name="Shape 5"/>
-          <p:cNvSpPr/>
-          <p:nvPr/>
-        </p:nvSpPr>
-        <p:spPr>
-          <a:xfrm>
-            <a:off x="8708354" y="0"/>
-            <a:ext cx="1750815" cy="128016"/>
-          </a:xfrm>
-          <a:prstGeom prst="rect">
-            <a:avLst/>
-          </a:prstGeom>
-          <a:solidFill>
-            <a:srgbClr val="74C0FC"/>
-          </a:solidFill>
-          <a:ln w="12700">
-            <a:solidFill>
-              <a:srgbClr val="74C0FC"/>
-            </a:solidFill>
-            <a:prstDash val="solid"/>
-          </a:ln>
-        </p:spPr>
-      </p:sp>
-      <p:sp>
-        <p:nvSpPr>
-          <p:cNvPr id="8" name="Shape 6"/>
-          <p:cNvSpPr/>
-          <p:nvPr/>
-        </p:nvSpPr>
-        <p:spPr>
-          <a:xfrm>
-            <a:off x="10450024" y="0"/>
-            <a:ext cx="1750815" cy="128016"/>
-          </a:xfrm>
-          <a:prstGeom prst="rect">
-            <a:avLst/>
-          </a:prstGeom>
-          <a:solidFill>
-            <a:srgbClr val="B197FC"/>
-          </a:solidFill>
-          <a:ln w="12700">
-            <a:solidFill>
-              <a:srgbClr val="B197FC"/>
-            </a:solidFill>
-            <a:prstDash val="solid"/>
-          </a:ln>
-        </p:spPr>
-      </p:sp>
-      <p:sp>
-        <p:nvSpPr>
-          <p:cNvPr id="9" name="Text 7"/>
+          <p:cNvPr id="3" name="Text 1"/>
           <p:cNvSpPr/>
           <p:nvPr/>
         </p:nvSpPr>
@@ -13796,7 +12737,7 @@
       </p:sp>
       <p:sp>
         <p:nvSpPr>
-          <p:cNvPr id="10" name="Text 8"/>
+          <p:cNvPr id="4" name="Text 2"/>
           <p:cNvSpPr/>
           <p:nvPr/>
         </p:nvSpPr>
@@ -13837,7 +12778,7 @@
       </p:sp>
       <p:sp>
         <p:nvSpPr>
-          <p:cNvPr id="11" name="Text 9"/>
+          <p:cNvPr id="5" name="Text 3"/>
           <p:cNvSpPr/>
           <p:nvPr/>
         </p:nvSpPr>
@@ -17700,17 +16641,17 @@
         <p:spPr>
           <a:xfrm>
             <a:off x="822960" y="3703320"/>
-            <a:ext cx="1502229" cy="164592"/>
+            <a:ext cx="10515600" cy="164592"/>
           </a:xfrm>
           <a:prstGeom prst="rect">
             <a:avLst/>
           </a:prstGeom>
           <a:solidFill>
-            <a:srgbClr val="FF6B6B"/>
+            <a:srgbClr val="6CC3FF"/>
           </a:solidFill>
           <a:ln w="12700">
             <a:solidFill>
-              <a:srgbClr val="FF6B6B"/>
+              <a:srgbClr val="6CC3FF"/>
             </a:solidFill>
             <a:prstDash val="solid"/>
           </a:ln>
@@ -17718,157 +16659,7 @@
       </p:sp>
       <p:sp>
         <p:nvSpPr>
-          <p:cNvPr id="14" name="Shape 12"/>
-          <p:cNvSpPr/>
-          <p:nvPr/>
-        </p:nvSpPr>
-        <p:spPr>
-          <a:xfrm>
-            <a:off x="2325189" y="3703320"/>
-            <a:ext cx="1502229" cy="164592"/>
-          </a:xfrm>
-          <a:prstGeom prst="rect">
-            <a:avLst/>
-          </a:prstGeom>
-          <a:solidFill>
-            <a:srgbClr val="FFA94D"/>
-          </a:solidFill>
-          <a:ln w="12700">
-            <a:solidFill>
-              <a:srgbClr val="FFA94D"/>
-            </a:solidFill>
-            <a:prstDash val="solid"/>
-          </a:ln>
-        </p:spPr>
-      </p:sp>
-      <p:sp>
-        <p:nvSpPr>
-          <p:cNvPr id="15" name="Shape 13"/>
-          <p:cNvSpPr/>
-          <p:nvPr/>
-        </p:nvSpPr>
-        <p:spPr>
-          <a:xfrm>
-            <a:off x="3827417" y="3703320"/>
-            <a:ext cx="1502229" cy="164592"/>
-          </a:xfrm>
-          <a:prstGeom prst="rect">
-            <a:avLst/>
-          </a:prstGeom>
-          <a:solidFill>
-            <a:srgbClr val="FFE066"/>
-          </a:solidFill>
-          <a:ln w="12700">
-            <a:solidFill>
-              <a:srgbClr val="FFE066"/>
-            </a:solidFill>
-            <a:prstDash val="solid"/>
-          </a:ln>
-        </p:spPr>
-      </p:sp>
-      <p:sp>
-        <p:nvSpPr>
-          <p:cNvPr id="16" name="Shape 14"/>
-          <p:cNvSpPr/>
-          <p:nvPr/>
-        </p:nvSpPr>
-        <p:spPr>
-          <a:xfrm>
-            <a:off x="5329646" y="3703320"/>
-            <a:ext cx="1502229" cy="164592"/>
-          </a:xfrm>
-          <a:prstGeom prst="rect">
-            <a:avLst/>
-          </a:prstGeom>
-          <a:solidFill>
-            <a:srgbClr val="8CE99A"/>
-          </a:solidFill>
-          <a:ln w="12700">
-            <a:solidFill>
-              <a:srgbClr val="8CE99A"/>
-            </a:solidFill>
-            <a:prstDash val="solid"/>
-          </a:ln>
-        </p:spPr>
-      </p:sp>
-      <p:sp>
-        <p:nvSpPr>
-          <p:cNvPr id="17" name="Shape 15"/>
-          <p:cNvSpPr/>
-          <p:nvPr/>
-        </p:nvSpPr>
-        <p:spPr>
-          <a:xfrm>
-            <a:off x="6831874" y="3703320"/>
-            <a:ext cx="1502229" cy="164592"/>
-          </a:xfrm>
-          <a:prstGeom prst="rect">
-            <a:avLst/>
-          </a:prstGeom>
-          <a:solidFill>
-            <a:srgbClr val="66D9E8"/>
-          </a:solidFill>
-          <a:ln w="12700">
-            <a:solidFill>
-              <a:srgbClr val="66D9E8"/>
-            </a:solidFill>
-            <a:prstDash val="solid"/>
-          </a:ln>
-        </p:spPr>
-      </p:sp>
-      <p:sp>
-        <p:nvSpPr>
-          <p:cNvPr id="18" name="Shape 16"/>
-          <p:cNvSpPr/>
-          <p:nvPr/>
-        </p:nvSpPr>
-        <p:spPr>
-          <a:xfrm>
-            <a:off x="8334103" y="3703320"/>
-            <a:ext cx="1502229" cy="164592"/>
-          </a:xfrm>
-          <a:prstGeom prst="rect">
-            <a:avLst/>
-          </a:prstGeom>
-          <a:solidFill>
-            <a:srgbClr val="74C0FC"/>
-          </a:solidFill>
-          <a:ln w="12700">
-            <a:solidFill>
-              <a:srgbClr val="74C0FC"/>
-            </a:solidFill>
-            <a:prstDash val="solid"/>
-          </a:ln>
-        </p:spPr>
-      </p:sp>
-      <p:sp>
-        <p:nvSpPr>
-          <p:cNvPr id="19" name="Shape 17"/>
-          <p:cNvSpPr/>
-          <p:nvPr/>
-        </p:nvSpPr>
-        <p:spPr>
-          <a:xfrm>
-            <a:off x="9836331" y="3703320"/>
-            <a:ext cx="1502229" cy="164592"/>
-          </a:xfrm>
-          <a:prstGeom prst="rect">
-            <a:avLst/>
-          </a:prstGeom>
-          <a:solidFill>
-            <a:srgbClr val="B197FC"/>
-          </a:solidFill>
-          <a:ln w="12700">
-            <a:solidFill>
-              <a:srgbClr val="B197FC"/>
-            </a:solidFill>
-            <a:prstDash val="solid"/>
-          </a:ln>
-        </p:spPr>
-      </p:sp>
-      <p:sp>
-        <p:nvSpPr>
-          <p:cNvPr id="20" name="Text 18"/>
+          <p:cNvPr id="14" name="Text 12"/>
           <p:cNvSpPr/>
           <p:nvPr/>
         </p:nvSpPr>
@@ -17907,7 +16698,7 @@
       </p:sp>
       <p:sp>
         <p:nvSpPr>
-          <p:cNvPr id="21" name="Text 19"/>
+          <p:cNvPr id="15" name="Text 13"/>
           <p:cNvSpPr/>
           <p:nvPr/>
         </p:nvSpPr>
@@ -17992,7 +16783,7 @@
       </p:sp>
       <p:sp>
         <p:nvSpPr>
-          <p:cNvPr id="22" name="Text 20"/>
+          <p:cNvPr id="16" name="Text 14"/>
           <p:cNvSpPr/>
           <p:nvPr/>
         </p:nvSpPr>
@@ -18031,7 +16822,7 @@
       </p:sp>
       <p:sp>
         <p:nvSpPr>
-          <p:cNvPr id="23" name="Text 21"/>
+          <p:cNvPr id="17" name="Text 15"/>
           <p:cNvSpPr/>
           <p:nvPr/>
         </p:nvSpPr>
@@ -18398,17 +17189,17 @@
         <p:spPr>
           <a:xfrm>
             <a:off x="0" y="0"/>
-            <a:ext cx="1750815" cy="128016"/>
+            <a:ext cx="12191695" cy="128016"/>
           </a:xfrm>
           <a:prstGeom prst="rect">
             <a:avLst/>
           </a:prstGeom>
           <a:solidFill>
-            <a:srgbClr val="FF6B6B"/>
+            <a:srgbClr val="6CC3FF"/>
           </a:solidFill>
           <a:ln w="12700">
             <a:solidFill>
-              <a:srgbClr val="FF6B6B"/>
+              <a:srgbClr val="6CC3FF"/>
             </a:solidFill>
             <a:prstDash val="solid"/>
           </a:ln>
@@ -18416,157 +17207,7 @@
       </p:sp>
       <p:sp>
         <p:nvSpPr>
-          <p:cNvPr id="3" name="Shape 1"/>
-          <p:cNvSpPr/>
-          <p:nvPr/>
-        </p:nvSpPr>
-        <p:spPr>
-          <a:xfrm>
-            <a:off x="1741671" y="0"/>
-            <a:ext cx="1750815" cy="128016"/>
-          </a:xfrm>
-          <a:prstGeom prst="rect">
-            <a:avLst/>
-          </a:prstGeom>
-          <a:solidFill>
-            <a:srgbClr val="FFA94D"/>
-          </a:solidFill>
-          <a:ln w="12700">
-            <a:solidFill>
-              <a:srgbClr val="FFA94D"/>
-            </a:solidFill>
-            <a:prstDash val="solid"/>
-          </a:ln>
-        </p:spPr>
-      </p:sp>
-      <p:sp>
-        <p:nvSpPr>
-          <p:cNvPr id="4" name="Shape 2"/>
-          <p:cNvSpPr/>
-          <p:nvPr/>
-        </p:nvSpPr>
-        <p:spPr>
-          <a:xfrm>
-            <a:off x="3483341" y="0"/>
-            <a:ext cx="1750815" cy="128016"/>
-          </a:xfrm>
-          <a:prstGeom prst="rect">
-            <a:avLst/>
-          </a:prstGeom>
-          <a:solidFill>
-            <a:srgbClr val="FFE066"/>
-          </a:solidFill>
-          <a:ln w="12700">
-            <a:solidFill>
-              <a:srgbClr val="FFE066"/>
-            </a:solidFill>
-            <a:prstDash val="solid"/>
-          </a:ln>
-        </p:spPr>
-      </p:sp>
-      <p:sp>
-        <p:nvSpPr>
-          <p:cNvPr id="5" name="Shape 3"/>
-          <p:cNvSpPr/>
-          <p:nvPr/>
-        </p:nvSpPr>
-        <p:spPr>
-          <a:xfrm>
-            <a:off x="5225012" y="0"/>
-            <a:ext cx="1750815" cy="128016"/>
-          </a:xfrm>
-          <a:prstGeom prst="rect">
-            <a:avLst/>
-          </a:prstGeom>
-          <a:solidFill>
-            <a:srgbClr val="8CE99A"/>
-          </a:solidFill>
-          <a:ln w="12700">
-            <a:solidFill>
-              <a:srgbClr val="8CE99A"/>
-            </a:solidFill>
-            <a:prstDash val="solid"/>
-          </a:ln>
-        </p:spPr>
-      </p:sp>
-      <p:sp>
-        <p:nvSpPr>
-          <p:cNvPr id="6" name="Shape 4"/>
-          <p:cNvSpPr/>
-          <p:nvPr/>
-        </p:nvSpPr>
-        <p:spPr>
-          <a:xfrm>
-            <a:off x="6966683" y="0"/>
-            <a:ext cx="1750815" cy="128016"/>
-          </a:xfrm>
-          <a:prstGeom prst="rect">
-            <a:avLst/>
-          </a:prstGeom>
-          <a:solidFill>
-            <a:srgbClr val="66D9E8"/>
-          </a:solidFill>
-          <a:ln w="12700">
-            <a:solidFill>
-              <a:srgbClr val="66D9E8"/>
-            </a:solidFill>
-            <a:prstDash val="solid"/>
-          </a:ln>
-        </p:spPr>
-      </p:sp>
-      <p:sp>
-        <p:nvSpPr>
-          <p:cNvPr id="7" name="Shape 5"/>
-          <p:cNvSpPr/>
-          <p:nvPr/>
-        </p:nvSpPr>
-        <p:spPr>
-          <a:xfrm>
-            <a:off x="8708354" y="0"/>
-            <a:ext cx="1750815" cy="128016"/>
-          </a:xfrm>
-          <a:prstGeom prst="rect">
-            <a:avLst/>
-          </a:prstGeom>
-          <a:solidFill>
-            <a:srgbClr val="74C0FC"/>
-          </a:solidFill>
-          <a:ln w="12700">
-            <a:solidFill>
-              <a:srgbClr val="74C0FC"/>
-            </a:solidFill>
-            <a:prstDash val="solid"/>
-          </a:ln>
-        </p:spPr>
-      </p:sp>
-      <p:sp>
-        <p:nvSpPr>
-          <p:cNvPr id="8" name="Shape 6"/>
-          <p:cNvSpPr/>
-          <p:nvPr/>
-        </p:nvSpPr>
-        <p:spPr>
-          <a:xfrm>
-            <a:off x="10450024" y="0"/>
-            <a:ext cx="1750815" cy="128016"/>
-          </a:xfrm>
-          <a:prstGeom prst="rect">
-            <a:avLst/>
-          </a:prstGeom>
-          <a:solidFill>
-            <a:srgbClr val="B197FC"/>
-          </a:solidFill>
-          <a:ln w="12700">
-            <a:solidFill>
-              <a:srgbClr val="B197FC"/>
-            </a:solidFill>
-            <a:prstDash val="solid"/>
-          </a:ln>
-        </p:spPr>
-      </p:sp>
-      <p:sp>
-        <p:nvSpPr>
-          <p:cNvPr id="9" name="Text 7"/>
+          <p:cNvPr id="3" name="Text 1"/>
           <p:cNvSpPr/>
           <p:nvPr/>
         </p:nvSpPr>
@@ -18605,7 +17246,7 @@
       </p:sp>
       <p:sp>
         <p:nvSpPr>
-          <p:cNvPr id="10" name="Text 8"/>
+          <p:cNvPr id="4" name="Text 2"/>
           <p:cNvSpPr/>
           <p:nvPr/>
         </p:nvSpPr>
@@ -18646,7 +17287,7 @@
       </p:sp>
       <p:sp>
         <p:nvSpPr>
-          <p:cNvPr id="11" name="Text 9"/>
+          <p:cNvPr id="5" name="Text 3"/>
           <p:cNvSpPr/>
           <p:nvPr/>
         </p:nvSpPr>
@@ -21727,17 +20368,17 @@
         <p:spPr>
           <a:xfrm>
             <a:off x="0" y="0"/>
-            <a:ext cx="1750815" cy="128016"/>
+            <a:ext cx="12191695" cy="128016"/>
           </a:xfrm>
           <a:prstGeom prst="rect">
             <a:avLst/>
           </a:prstGeom>
           <a:solidFill>
-            <a:srgbClr val="FF6B6B"/>
+            <a:srgbClr val="6CC3FF"/>
           </a:solidFill>
           <a:ln w="12700">
             <a:solidFill>
-              <a:srgbClr val="FF6B6B"/>
+              <a:srgbClr val="6CC3FF"/>
             </a:solidFill>
             <a:prstDash val="solid"/>
           </a:ln>
@@ -21745,157 +20386,7 @@
       </p:sp>
       <p:sp>
         <p:nvSpPr>
-          <p:cNvPr id="3" name="Shape 1"/>
-          <p:cNvSpPr/>
-          <p:nvPr/>
-        </p:nvSpPr>
-        <p:spPr>
-          <a:xfrm>
-            <a:off x="1741671" y="0"/>
-            <a:ext cx="1750815" cy="128016"/>
-          </a:xfrm>
-          <a:prstGeom prst="rect">
-            <a:avLst/>
-          </a:prstGeom>
-          <a:solidFill>
-            <a:srgbClr val="FFA94D"/>
-          </a:solidFill>
-          <a:ln w="12700">
-            <a:solidFill>
-              <a:srgbClr val="FFA94D"/>
-            </a:solidFill>
-            <a:prstDash val="solid"/>
-          </a:ln>
-        </p:spPr>
-      </p:sp>
-      <p:sp>
-        <p:nvSpPr>
-          <p:cNvPr id="4" name="Shape 2"/>
-          <p:cNvSpPr/>
-          <p:nvPr/>
-        </p:nvSpPr>
-        <p:spPr>
-          <a:xfrm>
-            <a:off x="3483341" y="0"/>
-            <a:ext cx="1750815" cy="128016"/>
-          </a:xfrm>
-          <a:prstGeom prst="rect">
-            <a:avLst/>
-          </a:prstGeom>
-          <a:solidFill>
-            <a:srgbClr val="FFE066"/>
-          </a:solidFill>
-          <a:ln w="12700">
-            <a:solidFill>
-              <a:srgbClr val="FFE066"/>
-            </a:solidFill>
-            <a:prstDash val="solid"/>
-          </a:ln>
-        </p:spPr>
-      </p:sp>
-      <p:sp>
-        <p:nvSpPr>
-          <p:cNvPr id="5" name="Shape 3"/>
-          <p:cNvSpPr/>
-          <p:nvPr/>
-        </p:nvSpPr>
-        <p:spPr>
-          <a:xfrm>
-            <a:off x="5225012" y="0"/>
-            <a:ext cx="1750815" cy="128016"/>
-          </a:xfrm>
-          <a:prstGeom prst="rect">
-            <a:avLst/>
-          </a:prstGeom>
-          <a:solidFill>
-            <a:srgbClr val="8CE99A"/>
-          </a:solidFill>
-          <a:ln w="12700">
-            <a:solidFill>
-              <a:srgbClr val="8CE99A"/>
-            </a:solidFill>
-            <a:prstDash val="solid"/>
-          </a:ln>
-        </p:spPr>
-      </p:sp>
-      <p:sp>
-        <p:nvSpPr>
-          <p:cNvPr id="6" name="Shape 4"/>
-          <p:cNvSpPr/>
-          <p:nvPr/>
-        </p:nvSpPr>
-        <p:spPr>
-          <a:xfrm>
-            <a:off x="6966683" y="0"/>
-            <a:ext cx="1750815" cy="128016"/>
-          </a:xfrm>
-          <a:prstGeom prst="rect">
-            <a:avLst/>
-          </a:prstGeom>
-          <a:solidFill>
-            <a:srgbClr val="66D9E8"/>
-          </a:solidFill>
-          <a:ln w="12700">
-            <a:solidFill>
-              <a:srgbClr val="66D9E8"/>
-            </a:solidFill>
-            <a:prstDash val="solid"/>
-          </a:ln>
-        </p:spPr>
-      </p:sp>
-      <p:sp>
-        <p:nvSpPr>
-          <p:cNvPr id="7" name="Shape 5"/>
-          <p:cNvSpPr/>
-          <p:nvPr/>
-        </p:nvSpPr>
-        <p:spPr>
-          <a:xfrm>
-            <a:off x="8708354" y="0"/>
-            <a:ext cx="1750815" cy="128016"/>
-          </a:xfrm>
-          <a:prstGeom prst="rect">
-            <a:avLst/>
-          </a:prstGeom>
-          <a:solidFill>
-            <a:srgbClr val="74C0FC"/>
-          </a:solidFill>
-          <a:ln w="12700">
-            <a:solidFill>
-              <a:srgbClr val="74C0FC"/>
-            </a:solidFill>
-            <a:prstDash val="solid"/>
-          </a:ln>
-        </p:spPr>
-      </p:sp>
-      <p:sp>
-        <p:nvSpPr>
-          <p:cNvPr id="8" name="Shape 6"/>
-          <p:cNvSpPr/>
-          <p:nvPr/>
-        </p:nvSpPr>
-        <p:spPr>
-          <a:xfrm>
-            <a:off x="10450024" y="0"/>
-            <a:ext cx="1750815" cy="128016"/>
-          </a:xfrm>
-          <a:prstGeom prst="rect">
-            <a:avLst/>
-          </a:prstGeom>
-          <a:solidFill>
-            <a:srgbClr val="B197FC"/>
-          </a:solidFill>
-          <a:ln w="12700">
-            <a:solidFill>
-              <a:srgbClr val="B197FC"/>
-            </a:solidFill>
-            <a:prstDash val="solid"/>
-          </a:ln>
-        </p:spPr>
-      </p:sp>
-      <p:sp>
-        <p:nvSpPr>
-          <p:cNvPr id="9" name="Text 7"/>
+          <p:cNvPr id="3" name="Text 1"/>
           <p:cNvSpPr/>
           <p:nvPr/>
         </p:nvSpPr>
@@ -21934,7 +20425,7 @@
       </p:sp>
       <p:sp>
         <p:nvSpPr>
-          <p:cNvPr id="10" name="Text 8"/>
+          <p:cNvPr id="4" name="Text 2"/>
           <p:cNvSpPr/>
           <p:nvPr/>
         </p:nvSpPr>
@@ -21975,7 +20466,7 @@
       </p:sp>
       <p:sp>
         <p:nvSpPr>
-          <p:cNvPr id="11" name="Text 9"/>
+          <p:cNvPr id="5" name="Text 3"/>
           <p:cNvSpPr/>
           <p:nvPr/>
         </p:nvSpPr>
@@ -26531,17 +25022,17 @@
         <p:spPr>
           <a:xfrm>
             <a:off x="0" y="0"/>
-            <a:ext cx="1750815" cy="128016"/>
+            <a:ext cx="12191695" cy="128016"/>
           </a:xfrm>
           <a:prstGeom prst="rect">
             <a:avLst/>
           </a:prstGeom>
           <a:solidFill>
-            <a:srgbClr val="FF6B6B"/>
+            <a:srgbClr val="6CC3FF"/>
           </a:solidFill>
           <a:ln w="12700">
             <a:solidFill>
-              <a:srgbClr val="FF6B6B"/>
+              <a:srgbClr val="6CC3FF"/>
             </a:solidFill>
             <a:prstDash val="solid"/>
           </a:ln>
@@ -26549,157 +25040,7 @@
       </p:sp>
       <p:sp>
         <p:nvSpPr>
-          <p:cNvPr id="3" name="Shape 1"/>
-          <p:cNvSpPr/>
-          <p:nvPr/>
-        </p:nvSpPr>
-        <p:spPr>
-          <a:xfrm>
-            <a:off x="1741671" y="0"/>
-            <a:ext cx="1750815" cy="128016"/>
-          </a:xfrm>
-          <a:prstGeom prst="rect">
-            <a:avLst/>
-          </a:prstGeom>
-          <a:solidFill>
-            <a:srgbClr val="FFA94D"/>
-          </a:solidFill>
-          <a:ln w="12700">
-            <a:solidFill>
-              <a:srgbClr val="FFA94D"/>
-            </a:solidFill>
-            <a:prstDash val="solid"/>
-          </a:ln>
-        </p:spPr>
-      </p:sp>
-      <p:sp>
-        <p:nvSpPr>
-          <p:cNvPr id="4" name="Shape 2"/>
-          <p:cNvSpPr/>
-          <p:nvPr/>
-        </p:nvSpPr>
-        <p:spPr>
-          <a:xfrm>
-            <a:off x="3483341" y="0"/>
-            <a:ext cx="1750815" cy="128016"/>
-          </a:xfrm>
-          <a:prstGeom prst="rect">
-            <a:avLst/>
-          </a:prstGeom>
-          <a:solidFill>
-            <a:srgbClr val="FFE066"/>
-          </a:solidFill>
-          <a:ln w="12700">
-            <a:solidFill>
-              <a:srgbClr val="FFE066"/>
-            </a:solidFill>
-            <a:prstDash val="solid"/>
-          </a:ln>
-        </p:spPr>
-      </p:sp>
-      <p:sp>
-        <p:nvSpPr>
-          <p:cNvPr id="5" name="Shape 3"/>
-          <p:cNvSpPr/>
-          <p:nvPr/>
-        </p:nvSpPr>
-        <p:spPr>
-          <a:xfrm>
-            <a:off x="5225012" y="0"/>
-            <a:ext cx="1750815" cy="128016"/>
-          </a:xfrm>
-          <a:prstGeom prst="rect">
-            <a:avLst/>
-          </a:prstGeom>
-          <a:solidFill>
-            <a:srgbClr val="8CE99A"/>
-          </a:solidFill>
-          <a:ln w="12700">
-            <a:solidFill>
-              <a:srgbClr val="8CE99A"/>
-            </a:solidFill>
-            <a:prstDash val="solid"/>
-          </a:ln>
-        </p:spPr>
-      </p:sp>
-      <p:sp>
-        <p:nvSpPr>
-          <p:cNvPr id="6" name="Shape 4"/>
-          <p:cNvSpPr/>
-          <p:nvPr/>
-        </p:nvSpPr>
-        <p:spPr>
-          <a:xfrm>
-            <a:off x="6966683" y="0"/>
-            <a:ext cx="1750815" cy="128016"/>
-          </a:xfrm>
-          <a:prstGeom prst="rect">
-            <a:avLst/>
-          </a:prstGeom>
-          <a:solidFill>
-            <a:srgbClr val="66D9E8"/>
-          </a:solidFill>
-          <a:ln w="12700">
-            <a:solidFill>
-              <a:srgbClr val="66D9E8"/>
-            </a:solidFill>
-            <a:prstDash val="solid"/>
-          </a:ln>
-        </p:spPr>
-      </p:sp>
-      <p:sp>
-        <p:nvSpPr>
-          <p:cNvPr id="7" name="Shape 5"/>
-          <p:cNvSpPr/>
-          <p:nvPr/>
-        </p:nvSpPr>
-        <p:spPr>
-          <a:xfrm>
-            <a:off x="8708354" y="0"/>
-            <a:ext cx="1750815" cy="128016"/>
-          </a:xfrm>
-          <a:prstGeom prst="rect">
-            <a:avLst/>
-          </a:prstGeom>
-          <a:solidFill>
-            <a:srgbClr val="74C0FC"/>
-          </a:solidFill>
-          <a:ln w="12700">
-            <a:solidFill>
-              <a:srgbClr val="74C0FC"/>
-            </a:solidFill>
-            <a:prstDash val="solid"/>
-          </a:ln>
-        </p:spPr>
-      </p:sp>
-      <p:sp>
-        <p:nvSpPr>
-          <p:cNvPr id="8" name="Shape 6"/>
-          <p:cNvSpPr/>
-          <p:nvPr/>
-        </p:nvSpPr>
-        <p:spPr>
-          <a:xfrm>
-            <a:off x="10450024" y="0"/>
-            <a:ext cx="1750815" cy="128016"/>
-          </a:xfrm>
-          <a:prstGeom prst="rect">
-            <a:avLst/>
-          </a:prstGeom>
-          <a:solidFill>
-            <a:srgbClr val="B197FC"/>
-          </a:solidFill>
-          <a:ln w="12700">
-            <a:solidFill>
-              <a:srgbClr val="B197FC"/>
-            </a:solidFill>
-            <a:prstDash val="solid"/>
-          </a:ln>
-        </p:spPr>
-      </p:sp>
-      <p:sp>
-        <p:nvSpPr>
-          <p:cNvPr id="9" name="Text 7"/>
+          <p:cNvPr id="3" name="Text 1"/>
           <p:cNvSpPr/>
           <p:nvPr/>
         </p:nvSpPr>
@@ -26738,7 +25079,7 @@
       </p:sp>
       <p:sp>
         <p:nvSpPr>
-          <p:cNvPr id="10" name="Text 8"/>
+          <p:cNvPr id="4" name="Text 2"/>
           <p:cNvSpPr/>
           <p:nvPr/>
         </p:nvSpPr>
@@ -26779,7 +25120,7 @@
       </p:sp>
       <p:sp>
         <p:nvSpPr>
-          <p:cNvPr id="11" name="Text 9"/>
+          <p:cNvPr id="5" name="Text 3"/>
           <p:cNvSpPr/>
           <p:nvPr/>
         </p:nvSpPr>
@@ -31570,17 +29911,17 @@
         <p:spPr>
           <a:xfrm>
             <a:off x="0" y="0"/>
-            <a:ext cx="1750815" cy="128016"/>
+            <a:ext cx="12191695" cy="128016"/>
           </a:xfrm>
           <a:prstGeom prst="rect">
             <a:avLst/>
           </a:prstGeom>
           <a:solidFill>
-            <a:srgbClr val="FF6B6B"/>
+            <a:srgbClr val="6CC3FF"/>
           </a:solidFill>
           <a:ln w="12700">
             <a:solidFill>
-              <a:srgbClr val="FF6B6B"/>
+              <a:srgbClr val="6CC3FF"/>
             </a:solidFill>
             <a:prstDash val="solid"/>
           </a:ln>
@@ -31588,157 +29929,7 @@
       </p:sp>
       <p:sp>
         <p:nvSpPr>
-          <p:cNvPr id="3" name="Shape 1"/>
-          <p:cNvSpPr/>
-          <p:nvPr/>
-        </p:nvSpPr>
-        <p:spPr>
-          <a:xfrm>
-            <a:off x="1741671" y="0"/>
-            <a:ext cx="1750815" cy="128016"/>
-          </a:xfrm>
-          <a:prstGeom prst="rect">
-            <a:avLst/>
-          </a:prstGeom>
-          <a:solidFill>
-            <a:srgbClr val="FFA94D"/>
-          </a:solidFill>
-          <a:ln w="12700">
-            <a:solidFill>
-              <a:srgbClr val="FFA94D"/>
-            </a:solidFill>
-            <a:prstDash val="solid"/>
-          </a:ln>
-        </p:spPr>
-      </p:sp>
-      <p:sp>
-        <p:nvSpPr>
-          <p:cNvPr id="4" name="Shape 2"/>
-          <p:cNvSpPr/>
-          <p:nvPr/>
-        </p:nvSpPr>
-        <p:spPr>
-          <a:xfrm>
-            <a:off x="3483341" y="0"/>
-            <a:ext cx="1750815" cy="128016"/>
-          </a:xfrm>
-          <a:prstGeom prst="rect">
-            <a:avLst/>
-          </a:prstGeom>
-          <a:solidFill>
-            <a:srgbClr val="FFE066"/>
-          </a:solidFill>
-          <a:ln w="12700">
-            <a:solidFill>
-              <a:srgbClr val="FFE066"/>
-            </a:solidFill>
-            <a:prstDash val="solid"/>
-          </a:ln>
-        </p:spPr>
-      </p:sp>
-      <p:sp>
-        <p:nvSpPr>
-          <p:cNvPr id="5" name="Shape 3"/>
-          <p:cNvSpPr/>
-          <p:nvPr/>
-        </p:nvSpPr>
-        <p:spPr>
-          <a:xfrm>
-            <a:off x="5225012" y="0"/>
-            <a:ext cx="1750815" cy="128016"/>
-          </a:xfrm>
-          <a:prstGeom prst="rect">
-            <a:avLst/>
-          </a:prstGeom>
-          <a:solidFill>
-            <a:srgbClr val="8CE99A"/>
-          </a:solidFill>
-          <a:ln w="12700">
-            <a:solidFill>
-              <a:srgbClr val="8CE99A"/>
-            </a:solidFill>
-            <a:prstDash val="solid"/>
-          </a:ln>
-        </p:spPr>
-      </p:sp>
-      <p:sp>
-        <p:nvSpPr>
-          <p:cNvPr id="6" name="Shape 4"/>
-          <p:cNvSpPr/>
-          <p:nvPr/>
-        </p:nvSpPr>
-        <p:spPr>
-          <a:xfrm>
-            <a:off x="6966683" y="0"/>
-            <a:ext cx="1750815" cy="128016"/>
-          </a:xfrm>
-          <a:prstGeom prst="rect">
-            <a:avLst/>
-          </a:prstGeom>
-          <a:solidFill>
-            <a:srgbClr val="66D9E8"/>
-          </a:solidFill>
-          <a:ln w="12700">
-            <a:solidFill>
-              <a:srgbClr val="66D9E8"/>
-            </a:solidFill>
-            <a:prstDash val="solid"/>
-          </a:ln>
-        </p:spPr>
-      </p:sp>
-      <p:sp>
-        <p:nvSpPr>
-          <p:cNvPr id="7" name="Shape 5"/>
-          <p:cNvSpPr/>
-          <p:nvPr/>
-        </p:nvSpPr>
-        <p:spPr>
-          <a:xfrm>
-            <a:off x="8708354" y="0"/>
-            <a:ext cx="1750815" cy="128016"/>
-          </a:xfrm>
-          <a:prstGeom prst="rect">
-            <a:avLst/>
-          </a:prstGeom>
-          <a:solidFill>
-            <a:srgbClr val="74C0FC"/>
-          </a:solidFill>
-          <a:ln w="12700">
-            <a:solidFill>
-              <a:srgbClr val="74C0FC"/>
-            </a:solidFill>
-            <a:prstDash val="solid"/>
-          </a:ln>
-        </p:spPr>
-      </p:sp>
-      <p:sp>
-        <p:nvSpPr>
-          <p:cNvPr id="8" name="Shape 6"/>
-          <p:cNvSpPr/>
-          <p:nvPr/>
-        </p:nvSpPr>
-        <p:spPr>
-          <a:xfrm>
-            <a:off x="10450024" y="0"/>
-            <a:ext cx="1750815" cy="128016"/>
-          </a:xfrm>
-          <a:prstGeom prst="rect">
-            <a:avLst/>
-          </a:prstGeom>
-          <a:solidFill>
-            <a:srgbClr val="B197FC"/>
-          </a:solidFill>
-          <a:ln w="12700">
-            <a:solidFill>
-              <a:srgbClr val="B197FC"/>
-            </a:solidFill>
-            <a:prstDash val="solid"/>
-          </a:ln>
-        </p:spPr>
-      </p:sp>
-      <p:sp>
-        <p:nvSpPr>
-          <p:cNvPr id="9" name="Text 7"/>
+          <p:cNvPr id="3" name="Text 1"/>
           <p:cNvSpPr/>
           <p:nvPr/>
         </p:nvSpPr>
@@ -31777,7 +29968,7 @@
       </p:sp>
       <p:sp>
         <p:nvSpPr>
-          <p:cNvPr id="10" name="Text 8"/>
+          <p:cNvPr id="4" name="Text 2"/>
           <p:cNvSpPr/>
           <p:nvPr/>
         </p:nvSpPr>
@@ -31857,17 +30048,17 @@
         <p:spPr>
           <a:xfrm>
             <a:off x="0" y="0"/>
-            <a:ext cx="1750815" cy="128016"/>
+            <a:ext cx="12191695" cy="128016"/>
           </a:xfrm>
           <a:prstGeom prst="rect">
             <a:avLst/>
           </a:prstGeom>
           <a:solidFill>
-            <a:srgbClr val="FF6B6B"/>
+            <a:srgbClr val="6CC3FF"/>
           </a:solidFill>
           <a:ln w="12700">
             <a:solidFill>
-              <a:srgbClr val="FF6B6B"/>
+              <a:srgbClr val="6CC3FF"/>
             </a:solidFill>
             <a:prstDash val="solid"/>
           </a:ln>
@@ -31875,157 +30066,7 @@
       </p:sp>
       <p:sp>
         <p:nvSpPr>
-          <p:cNvPr id="3" name="Shape 1"/>
-          <p:cNvSpPr/>
-          <p:nvPr/>
-        </p:nvSpPr>
-        <p:spPr>
-          <a:xfrm>
-            <a:off x="1741671" y="0"/>
-            <a:ext cx="1750815" cy="128016"/>
-          </a:xfrm>
-          <a:prstGeom prst="rect">
-            <a:avLst/>
-          </a:prstGeom>
-          <a:solidFill>
-            <a:srgbClr val="FFA94D"/>
-          </a:solidFill>
-          <a:ln w="12700">
-            <a:solidFill>
-              <a:srgbClr val="FFA94D"/>
-            </a:solidFill>
-            <a:prstDash val="solid"/>
-          </a:ln>
-        </p:spPr>
-      </p:sp>
-      <p:sp>
-        <p:nvSpPr>
-          <p:cNvPr id="4" name="Shape 2"/>
-          <p:cNvSpPr/>
-          <p:nvPr/>
-        </p:nvSpPr>
-        <p:spPr>
-          <a:xfrm>
-            <a:off x="3483341" y="0"/>
-            <a:ext cx="1750815" cy="128016"/>
-          </a:xfrm>
-          <a:prstGeom prst="rect">
-            <a:avLst/>
-          </a:prstGeom>
-          <a:solidFill>
-            <a:srgbClr val="FFE066"/>
-          </a:solidFill>
-          <a:ln w="12700">
-            <a:solidFill>
-              <a:srgbClr val="FFE066"/>
-            </a:solidFill>
-            <a:prstDash val="solid"/>
-          </a:ln>
-        </p:spPr>
-      </p:sp>
-      <p:sp>
-        <p:nvSpPr>
-          <p:cNvPr id="5" name="Shape 3"/>
-          <p:cNvSpPr/>
-          <p:nvPr/>
-        </p:nvSpPr>
-        <p:spPr>
-          <a:xfrm>
-            <a:off x="5225012" y="0"/>
-            <a:ext cx="1750815" cy="128016"/>
-          </a:xfrm>
-          <a:prstGeom prst="rect">
-            <a:avLst/>
-          </a:prstGeom>
-          <a:solidFill>
-            <a:srgbClr val="8CE99A"/>
-          </a:solidFill>
-          <a:ln w="12700">
-            <a:solidFill>
-              <a:srgbClr val="8CE99A"/>
-            </a:solidFill>
-            <a:prstDash val="solid"/>
-          </a:ln>
-        </p:spPr>
-      </p:sp>
-      <p:sp>
-        <p:nvSpPr>
-          <p:cNvPr id="6" name="Shape 4"/>
-          <p:cNvSpPr/>
-          <p:nvPr/>
-        </p:nvSpPr>
-        <p:spPr>
-          <a:xfrm>
-            <a:off x="6966683" y="0"/>
-            <a:ext cx="1750815" cy="128016"/>
-          </a:xfrm>
-          <a:prstGeom prst="rect">
-            <a:avLst/>
-          </a:prstGeom>
-          <a:solidFill>
-            <a:srgbClr val="66D9E8"/>
-          </a:solidFill>
-          <a:ln w="12700">
-            <a:solidFill>
-              <a:srgbClr val="66D9E8"/>
-            </a:solidFill>
-            <a:prstDash val="solid"/>
-          </a:ln>
-        </p:spPr>
-      </p:sp>
-      <p:sp>
-        <p:nvSpPr>
-          <p:cNvPr id="7" name="Shape 5"/>
-          <p:cNvSpPr/>
-          <p:nvPr/>
-        </p:nvSpPr>
-        <p:spPr>
-          <a:xfrm>
-            <a:off x="8708354" y="0"/>
-            <a:ext cx="1750815" cy="128016"/>
-          </a:xfrm>
-          <a:prstGeom prst="rect">
-            <a:avLst/>
-          </a:prstGeom>
-          <a:solidFill>
-            <a:srgbClr val="74C0FC"/>
-          </a:solidFill>
-          <a:ln w="12700">
-            <a:solidFill>
-              <a:srgbClr val="74C0FC"/>
-            </a:solidFill>
-            <a:prstDash val="solid"/>
-          </a:ln>
-        </p:spPr>
-      </p:sp>
-      <p:sp>
-        <p:nvSpPr>
-          <p:cNvPr id="8" name="Shape 6"/>
-          <p:cNvSpPr/>
-          <p:nvPr/>
-        </p:nvSpPr>
-        <p:spPr>
-          <a:xfrm>
-            <a:off x="10450024" y="0"/>
-            <a:ext cx="1750815" cy="128016"/>
-          </a:xfrm>
-          <a:prstGeom prst="rect">
-            <a:avLst/>
-          </a:prstGeom>
-          <a:solidFill>
-            <a:srgbClr val="B197FC"/>
-          </a:solidFill>
-          <a:ln w="12700">
-            <a:solidFill>
-              <a:srgbClr val="B197FC"/>
-            </a:solidFill>
-            <a:prstDash val="solid"/>
-          </a:ln>
-        </p:spPr>
-      </p:sp>
-      <p:sp>
-        <p:nvSpPr>
-          <p:cNvPr id="9" name="Text 7"/>
+          <p:cNvPr id="3" name="Text 1"/>
           <p:cNvSpPr/>
           <p:nvPr/>
         </p:nvSpPr>
@@ -32064,7 +30105,7 @@
       </p:sp>
       <p:sp>
         <p:nvSpPr>
-          <p:cNvPr id="10" name="Text 8"/>
+          <p:cNvPr id="4" name="Text 2"/>
           <p:cNvSpPr/>
           <p:nvPr/>
         </p:nvSpPr>
@@ -32105,7 +30146,7 @@
       </p:sp>
       <p:sp>
         <p:nvSpPr>
-          <p:cNvPr id="11" name="Text 9"/>
+          <p:cNvPr id="5" name="Text 3"/>
           <p:cNvSpPr/>
           <p:nvPr/>
         </p:nvSpPr>
@@ -34018,17 +32059,17 @@
         <p:spPr>
           <a:xfrm>
             <a:off x="0" y="0"/>
-            <a:ext cx="1750815" cy="128016"/>
+            <a:ext cx="12191695" cy="128016"/>
           </a:xfrm>
           <a:prstGeom prst="rect">
             <a:avLst/>
           </a:prstGeom>
           <a:solidFill>
-            <a:srgbClr val="FF6B6B"/>
+            <a:srgbClr val="6CC3FF"/>
           </a:solidFill>
           <a:ln w="12700">
             <a:solidFill>
-              <a:srgbClr val="FF6B6B"/>
+              <a:srgbClr val="6CC3FF"/>
             </a:solidFill>
             <a:prstDash val="solid"/>
           </a:ln>
@@ -34036,157 +32077,7 @@
       </p:sp>
       <p:sp>
         <p:nvSpPr>
-          <p:cNvPr id="3" name="Shape 1"/>
-          <p:cNvSpPr/>
-          <p:nvPr/>
-        </p:nvSpPr>
-        <p:spPr>
-          <a:xfrm>
-            <a:off x="1741671" y="0"/>
-            <a:ext cx="1750815" cy="128016"/>
-          </a:xfrm>
-          <a:prstGeom prst="rect">
-            <a:avLst/>
-          </a:prstGeom>
-          <a:solidFill>
-            <a:srgbClr val="FFA94D"/>
-          </a:solidFill>
-          <a:ln w="12700">
-            <a:solidFill>
-              <a:srgbClr val="FFA94D"/>
-            </a:solidFill>
-            <a:prstDash val="solid"/>
-          </a:ln>
-        </p:spPr>
-      </p:sp>
-      <p:sp>
-        <p:nvSpPr>
-          <p:cNvPr id="4" name="Shape 2"/>
-          <p:cNvSpPr/>
-          <p:nvPr/>
-        </p:nvSpPr>
-        <p:spPr>
-          <a:xfrm>
-            <a:off x="3483341" y="0"/>
-            <a:ext cx="1750815" cy="128016"/>
-          </a:xfrm>
-          <a:prstGeom prst="rect">
-            <a:avLst/>
-          </a:prstGeom>
-          <a:solidFill>
-            <a:srgbClr val="FFE066"/>
-          </a:solidFill>
-          <a:ln w="12700">
-            <a:solidFill>
-              <a:srgbClr val="FFE066"/>
-            </a:solidFill>
-            <a:prstDash val="solid"/>
-          </a:ln>
-        </p:spPr>
-      </p:sp>
-      <p:sp>
-        <p:nvSpPr>
-          <p:cNvPr id="5" name="Shape 3"/>
-          <p:cNvSpPr/>
-          <p:nvPr/>
-        </p:nvSpPr>
-        <p:spPr>
-          <a:xfrm>
-            <a:off x="5225012" y="0"/>
-            <a:ext cx="1750815" cy="128016"/>
-          </a:xfrm>
-          <a:prstGeom prst="rect">
-            <a:avLst/>
-          </a:prstGeom>
-          <a:solidFill>
-            <a:srgbClr val="8CE99A"/>
-          </a:solidFill>
-          <a:ln w="12700">
-            <a:solidFill>
-              <a:srgbClr val="8CE99A"/>
-            </a:solidFill>
-            <a:prstDash val="solid"/>
-          </a:ln>
-        </p:spPr>
-      </p:sp>
-      <p:sp>
-        <p:nvSpPr>
-          <p:cNvPr id="6" name="Shape 4"/>
-          <p:cNvSpPr/>
-          <p:nvPr/>
-        </p:nvSpPr>
-        <p:spPr>
-          <a:xfrm>
-            <a:off x="6966683" y="0"/>
-            <a:ext cx="1750815" cy="128016"/>
-          </a:xfrm>
-          <a:prstGeom prst="rect">
-            <a:avLst/>
-          </a:prstGeom>
-          <a:solidFill>
-            <a:srgbClr val="66D9E8"/>
-          </a:solidFill>
-          <a:ln w="12700">
-            <a:solidFill>
-              <a:srgbClr val="66D9E8"/>
-            </a:solidFill>
-            <a:prstDash val="solid"/>
-          </a:ln>
-        </p:spPr>
-      </p:sp>
-      <p:sp>
-        <p:nvSpPr>
-          <p:cNvPr id="7" name="Shape 5"/>
-          <p:cNvSpPr/>
-          <p:nvPr/>
-        </p:nvSpPr>
-        <p:spPr>
-          <a:xfrm>
-            <a:off x="8708354" y="0"/>
-            <a:ext cx="1750815" cy="128016"/>
-          </a:xfrm>
-          <a:prstGeom prst="rect">
-            <a:avLst/>
-          </a:prstGeom>
-          <a:solidFill>
-            <a:srgbClr val="74C0FC"/>
-          </a:solidFill>
-          <a:ln w="12700">
-            <a:solidFill>
-              <a:srgbClr val="74C0FC"/>
-            </a:solidFill>
-            <a:prstDash val="solid"/>
-          </a:ln>
-        </p:spPr>
-      </p:sp>
-      <p:sp>
-        <p:nvSpPr>
-          <p:cNvPr id="8" name="Shape 6"/>
-          <p:cNvSpPr/>
-          <p:nvPr/>
-        </p:nvSpPr>
-        <p:spPr>
-          <a:xfrm>
-            <a:off x="10450024" y="0"/>
-            <a:ext cx="1750815" cy="128016"/>
-          </a:xfrm>
-          <a:prstGeom prst="rect">
-            <a:avLst/>
-          </a:prstGeom>
-          <a:solidFill>
-            <a:srgbClr val="B197FC"/>
-          </a:solidFill>
-          <a:ln w="12700">
-            <a:solidFill>
-              <a:srgbClr val="B197FC"/>
-            </a:solidFill>
-            <a:prstDash val="solid"/>
-          </a:ln>
-        </p:spPr>
-      </p:sp>
-      <p:sp>
-        <p:nvSpPr>
-          <p:cNvPr id="9" name="Text 7"/>
+          <p:cNvPr id="3" name="Text 1"/>
           <p:cNvSpPr/>
           <p:nvPr/>
         </p:nvSpPr>
@@ -34225,7 +32116,7 @@
       </p:sp>
       <p:sp>
         <p:nvSpPr>
-          <p:cNvPr id="10" name="Text 8"/>
+          <p:cNvPr id="4" name="Text 2"/>
           <p:cNvSpPr/>
           <p:nvPr/>
         </p:nvSpPr>
@@ -34266,7 +32157,7 @@
       </p:sp>
       <p:sp>
         <p:nvSpPr>
-          <p:cNvPr id="11" name="Text 9"/>
+          <p:cNvPr id="5" name="Text 3"/>
           <p:cNvSpPr/>
           <p:nvPr/>
         </p:nvSpPr>
@@ -36526,17 +34417,17 @@
         <p:spPr>
           <a:xfrm>
             <a:off x="0" y="0"/>
-            <a:ext cx="1750815" cy="128016"/>
+            <a:ext cx="12191695" cy="128016"/>
           </a:xfrm>
           <a:prstGeom prst="rect">
             <a:avLst/>
           </a:prstGeom>
           <a:solidFill>
-            <a:srgbClr val="FF6B6B"/>
+            <a:srgbClr val="6CC3FF"/>
           </a:solidFill>
           <a:ln w="12700">
             <a:solidFill>
-              <a:srgbClr val="FF6B6B"/>
+              <a:srgbClr val="6CC3FF"/>
             </a:solidFill>
             <a:prstDash val="solid"/>
           </a:ln>
@@ -36544,157 +34435,7 @@
       </p:sp>
       <p:sp>
         <p:nvSpPr>
-          <p:cNvPr id="3" name="Shape 1"/>
-          <p:cNvSpPr/>
-          <p:nvPr/>
-        </p:nvSpPr>
-        <p:spPr>
-          <a:xfrm>
-            <a:off x="1741671" y="0"/>
-            <a:ext cx="1750815" cy="128016"/>
-          </a:xfrm>
-          <a:prstGeom prst="rect">
-            <a:avLst/>
-          </a:prstGeom>
-          <a:solidFill>
-            <a:srgbClr val="FFA94D"/>
-          </a:solidFill>
-          <a:ln w="12700">
-            <a:solidFill>
-              <a:srgbClr val="FFA94D"/>
-            </a:solidFill>
-            <a:prstDash val="solid"/>
-          </a:ln>
-        </p:spPr>
-      </p:sp>
-      <p:sp>
-        <p:nvSpPr>
-          <p:cNvPr id="4" name="Shape 2"/>
-          <p:cNvSpPr/>
-          <p:nvPr/>
-        </p:nvSpPr>
-        <p:spPr>
-          <a:xfrm>
-            <a:off x="3483341" y="0"/>
-            <a:ext cx="1750815" cy="128016"/>
-          </a:xfrm>
-          <a:prstGeom prst="rect">
-            <a:avLst/>
-          </a:prstGeom>
-          <a:solidFill>
-            <a:srgbClr val="FFE066"/>
-          </a:solidFill>
-          <a:ln w="12700">
-            <a:solidFill>
-              <a:srgbClr val="FFE066"/>
-            </a:solidFill>
-            <a:prstDash val="solid"/>
-          </a:ln>
-        </p:spPr>
-      </p:sp>
-      <p:sp>
-        <p:nvSpPr>
-          <p:cNvPr id="5" name="Shape 3"/>
-          <p:cNvSpPr/>
-          <p:nvPr/>
-        </p:nvSpPr>
-        <p:spPr>
-          <a:xfrm>
-            <a:off x="5225012" y="0"/>
-            <a:ext cx="1750815" cy="128016"/>
-          </a:xfrm>
-          <a:prstGeom prst="rect">
-            <a:avLst/>
-          </a:prstGeom>
-          <a:solidFill>
-            <a:srgbClr val="8CE99A"/>
-          </a:solidFill>
-          <a:ln w="12700">
-            <a:solidFill>
-              <a:srgbClr val="8CE99A"/>
-            </a:solidFill>
-            <a:prstDash val="solid"/>
-          </a:ln>
-        </p:spPr>
-      </p:sp>
-      <p:sp>
-        <p:nvSpPr>
-          <p:cNvPr id="6" name="Shape 4"/>
-          <p:cNvSpPr/>
-          <p:nvPr/>
-        </p:nvSpPr>
-        <p:spPr>
-          <a:xfrm>
-            <a:off x="6966683" y="0"/>
-            <a:ext cx="1750815" cy="128016"/>
-          </a:xfrm>
-          <a:prstGeom prst="rect">
-            <a:avLst/>
-          </a:prstGeom>
-          <a:solidFill>
-            <a:srgbClr val="66D9E8"/>
-          </a:solidFill>
-          <a:ln w="12700">
-            <a:solidFill>
-              <a:srgbClr val="66D9E8"/>
-            </a:solidFill>
-            <a:prstDash val="solid"/>
-          </a:ln>
-        </p:spPr>
-      </p:sp>
-      <p:sp>
-        <p:nvSpPr>
-          <p:cNvPr id="7" name="Shape 5"/>
-          <p:cNvSpPr/>
-          <p:nvPr/>
-        </p:nvSpPr>
-        <p:spPr>
-          <a:xfrm>
-            <a:off x="8708354" y="0"/>
-            <a:ext cx="1750815" cy="128016"/>
-          </a:xfrm>
-          <a:prstGeom prst="rect">
-            <a:avLst/>
-          </a:prstGeom>
-          <a:solidFill>
-            <a:srgbClr val="74C0FC"/>
-          </a:solidFill>
-          <a:ln w="12700">
-            <a:solidFill>
-              <a:srgbClr val="74C0FC"/>
-            </a:solidFill>
-            <a:prstDash val="solid"/>
-          </a:ln>
-        </p:spPr>
-      </p:sp>
-      <p:sp>
-        <p:nvSpPr>
-          <p:cNvPr id="8" name="Shape 6"/>
-          <p:cNvSpPr/>
-          <p:nvPr/>
-        </p:nvSpPr>
-        <p:spPr>
-          <a:xfrm>
-            <a:off x="10450024" y="0"/>
-            <a:ext cx="1750815" cy="128016"/>
-          </a:xfrm>
-          <a:prstGeom prst="rect">
-            <a:avLst/>
-          </a:prstGeom>
-          <a:solidFill>
-            <a:srgbClr val="B197FC"/>
-          </a:solidFill>
-          <a:ln w="12700">
-            <a:solidFill>
-              <a:srgbClr val="B197FC"/>
-            </a:solidFill>
-            <a:prstDash val="solid"/>
-          </a:ln>
-        </p:spPr>
-      </p:sp>
-      <p:sp>
-        <p:nvSpPr>
-          <p:cNvPr id="9" name="Text 7"/>
+          <p:cNvPr id="3" name="Text 1"/>
           <p:cNvSpPr/>
           <p:nvPr/>
         </p:nvSpPr>
@@ -36733,7 +34474,7 @@
       </p:sp>
       <p:sp>
         <p:nvSpPr>
-          <p:cNvPr id="10" name="Text 8"/>
+          <p:cNvPr id="4" name="Text 2"/>
           <p:cNvSpPr/>
           <p:nvPr/>
         </p:nvSpPr>
@@ -38898,17 +36639,17 @@
         <p:spPr>
           <a:xfrm>
             <a:off x="0" y="0"/>
-            <a:ext cx="1750815" cy="128016"/>
+            <a:ext cx="12191695" cy="128016"/>
           </a:xfrm>
           <a:prstGeom prst="rect">
             <a:avLst/>
           </a:prstGeom>
           <a:solidFill>
-            <a:srgbClr val="FF6B6B"/>
+            <a:srgbClr val="6CC3FF"/>
           </a:solidFill>
           <a:ln w="12700">
             <a:solidFill>
-              <a:srgbClr val="FF6B6B"/>
+              <a:srgbClr val="6CC3FF"/>
             </a:solidFill>
             <a:prstDash val="solid"/>
           </a:ln>
@@ -38916,157 +36657,7 @@
       </p:sp>
       <p:sp>
         <p:nvSpPr>
-          <p:cNvPr id="3" name="Shape 1"/>
-          <p:cNvSpPr/>
-          <p:nvPr/>
-        </p:nvSpPr>
-        <p:spPr>
-          <a:xfrm>
-            <a:off x="1741671" y="0"/>
-            <a:ext cx="1750815" cy="128016"/>
-          </a:xfrm>
-          <a:prstGeom prst="rect">
-            <a:avLst/>
-          </a:prstGeom>
-          <a:solidFill>
-            <a:srgbClr val="FFA94D"/>
-          </a:solidFill>
-          <a:ln w="12700">
-            <a:solidFill>
-              <a:srgbClr val="FFA94D"/>
-            </a:solidFill>
-            <a:prstDash val="solid"/>
-          </a:ln>
-        </p:spPr>
-      </p:sp>
-      <p:sp>
-        <p:nvSpPr>
-          <p:cNvPr id="4" name="Shape 2"/>
-          <p:cNvSpPr/>
-          <p:nvPr/>
-        </p:nvSpPr>
-        <p:spPr>
-          <a:xfrm>
-            <a:off x="3483341" y="0"/>
-            <a:ext cx="1750815" cy="128016"/>
-          </a:xfrm>
-          <a:prstGeom prst="rect">
-            <a:avLst/>
-          </a:prstGeom>
-          <a:solidFill>
-            <a:srgbClr val="FFE066"/>
-          </a:solidFill>
-          <a:ln w="12700">
-            <a:solidFill>
-              <a:srgbClr val="FFE066"/>
-            </a:solidFill>
-            <a:prstDash val="solid"/>
-          </a:ln>
-        </p:spPr>
-      </p:sp>
-      <p:sp>
-        <p:nvSpPr>
-          <p:cNvPr id="5" name="Shape 3"/>
-          <p:cNvSpPr/>
-          <p:nvPr/>
-        </p:nvSpPr>
-        <p:spPr>
-          <a:xfrm>
-            <a:off x="5225012" y="0"/>
-            <a:ext cx="1750815" cy="128016"/>
-          </a:xfrm>
-          <a:prstGeom prst="rect">
-            <a:avLst/>
-          </a:prstGeom>
-          <a:solidFill>
-            <a:srgbClr val="8CE99A"/>
-          </a:solidFill>
-          <a:ln w="12700">
-            <a:solidFill>
-              <a:srgbClr val="8CE99A"/>
-            </a:solidFill>
-            <a:prstDash val="solid"/>
-          </a:ln>
-        </p:spPr>
-      </p:sp>
-      <p:sp>
-        <p:nvSpPr>
-          <p:cNvPr id="6" name="Shape 4"/>
-          <p:cNvSpPr/>
-          <p:nvPr/>
-        </p:nvSpPr>
-        <p:spPr>
-          <a:xfrm>
-            <a:off x="6966683" y="0"/>
-            <a:ext cx="1750815" cy="128016"/>
-          </a:xfrm>
-          <a:prstGeom prst="rect">
-            <a:avLst/>
-          </a:prstGeom>
-          <a:solidFill>
-            <a:srgbClr val="66D9E8"/>
-          </a:solidFill>
-          <a:ln w="12700">
-            <a:solidFill>
-              <a:srgbClr val="66D9E8"/>
-            </a:solidFill>
-            <a:prstDash val="solid"/>
-          </a:ln>
-        </p:spPr>
-      </p:sp>
-      <p:sp>
-        <p:nvSpPr>
-          <p:cNvPr id="7" name="Shape 5"/>
-          <p:cNvSpPr/>
-          <p:nvPr/>
-        </p:nvSpPr>
-        <p:spPr>
-          <a:xfrm>
-            <a:off x="8708354" y="0"/>
-            <a:ext cx="1750815" cy="128016"/>
-          </a:xfrm>
-          <a:prstGeom prst="rect">
-            <a:avLst/>
-          </a:prstGeom>
-          <a:solidFill>
-            <a:srgbClr val="74C0FC"/>
-          </a:solidFill>
-          <a:ln w="12700">
-            <a:solidFill>
-              <a:srgbClr val="74C0FC"/>
-            </a:solidFill>
-            <a:prstDash val="solid"/>
-          </a:ln>
-        </p:spPr>
-      </p:sp>
-      <p:sp>
-        <p:nvSpPr>
-          <p:cNvPr id="8" name="Shape 6"/>
-          <p:cNvSpPr/>
-          <p:nvPr/>
-        </p:nvSpPr>
-        <p:spPr>
-          <a:xfrm>
-            <a:off x="10450024" y="0"/>
-            <a:ext cx="1750815" cy="128016"/>
-          </a:xfrm>
-          <a:prstGeom prst="rect">
-            <a:avLst/>
-          </a:prstGeom>
-          <a:solidFill>
-            <a:srgbClr val="B197FC"/>
-          </a:solidFill>
-          <a:ln w="12700">
-            <a:solidFill>
-              <a:srgbClr val="B197FC"/>
-            </a:solidFill>
-            <a:prstDash val="solid"/>
-          </a:ln>
-        </p:spPr>
-      </p:sp>
-      <p:sp>
-        <p:nvSpPr>
-          <p:cNvPr id="9" name="Text 7"/>
+          <p:cNvPr id="3" name="Text 1"/>
           <p:cNvSpPr/>
           <p:nvPr/>
         </p:nvSpPr>
@@ -39105,7 +36696,7 @@
       </p:sp>
       <p:sp>
         <p:nvSpPr>
-          <p:cNvPr id="10" name="Text 8"/>
+          <p:cNvPr id="4" name="Text 2"/>
           <p:cNvSpPr/>
           <p:nvPr/>
         </p:nvSpPr>
@@ -39146,7 +36737,7 @@
       </p:sp>
       <p:sp>
         <p:nvSpPr>
-          <p:cNvPr id="11" name="Text 9"/>
+          <p:cNvPr id="5" name="Text 3"/>
           <p:cNvSpPr/>
           <p:nvPr/>
         </p:nvSpPr>

</xml_diff>

<commit_message>
Regenerate session deck from the current outline (no speaker notes)
Co-Authored-By: Claude Sonnet 5.5 <noreply@anthropic.com>
Claude-Session: https://claude.ai/code/session_01Uxvsacj8MUMnaa96HiSWma
</commit_message>
<xml_diff>
--- a/presentation/AVD_Anywhere_NIC2026.pptx
+++ b/presentation/AVD_Anywhere_NIC2026.pptx
@@ -17643,7 +17643,7 @@
                 <a:latin typeface="Roboto"/>
                 <a:cs typeface="Roboto"/>
               </a:rPr>
-              <a:t>Plan and discover; deploy and Day-2 ready; operate</a:t>
+              <a:t>Thu 15 Oct, 09:50, Room 5: plan and discover; deploy and Day-2 ready; operate</a:t>
             </a:r>
           </a:p>
         </p:txBody>
@@ -18737,427 +18737,74 @@
       </p:sp>
       <p:sp>
         <p:nvSpPr>
-          <p:cNvPr id="4" name="Card 4"/>
-          <p:cNvSpPr/>
-          <p:nvPr/>
-        </p:nvSpPr>
-        <p:spPr>
-          <a:xfrm>
-            <a:off x="457200" y="1853184"/>
-            <a:ext cx="1920240" cy="2164080"/>
-          </a:xfrm>
-          <a:prstGeom prst="roundRect">
-            <a:avLst>
-              <a:gd name="adj" fmla="val 6000"/>
-            </a:avLst>
-          </a:prstGeom>
-          <a:solidFill>
-            <a:srgbClr val="FFFFFF"/>
-          </a:solidFill>
-          <a:ln w="19050">
-            <a:solidFill>
-              <a:srgbClr val="193233"/>
-            </a:solidFill>
-          </a:ln>
-        </p:spPr>
-        <p:txBody>
-          <a:bodyPr rtlCol="0" anchor="ctr"/>
-          <a:lstStyle/>
-          <a:p>
-            <a:endParaRPr lang="en-US" dirty="0"/>
-          </a:p>
-        </p:txBody>
-      </p:sp>
-      <p:sp>
-        <p:nvSpPr>
-          <p:cNvPr id="5" name="Rule 5"/>
-          <p:cNvSpPr/>
-          <p:nvPr/>
-        </p:nvSpPr>
-        <p:spPr>
-          <a:xfrm>
-            <a:off x="621792" y="2036064"/>
-            <a:ext cx="457200" cy="64008"/>
-          </a:xfrm>
-          <a:prstGeom prst="rect">
-            <a:avLst/>
-          </a:prstGeom>
-          <a:solidFill>
-            <a:srgbClr val="FDBA12"/>
-          </a:solidFill>
-          <a:ln>
-            <a:noFill/>
-          </a:ln>
-        </p:spPr>
-        <p:txBody>
-          <a:bodyPr rtlCol="0" anchor="ctr"/>
-          <a:lstStyle/>
-          <a:p>
-            <a:endParaRPr lang="en-US" dirty="0"/>
-          </a:p>
-        </p:txBody>
-      </p:sp>
-      <p:sp>
-        <p:nvSpPr>
-          <p:cNvPr id="6" name="Text 6"/>
-          <p:cNvSpPr txBox="1"/>
-          <p:nvPr/>
-        </p:nvSpPr>
-        <p:spPr>
-          <a:xfrm>
-            <a:off x="548640" y="2173224"/>
-            <a:ext cx="1737360" cy="1752600"/>
-          </a:xfrm>
-          <a:prstGeom prst="rect">
-            <a:avLst/>
-          </a:prstGeom>
-          <a:noFill/>
-          <a:ln>
-            <a:noFill/>
-          </a:ln>
-        </p:spPr>
-        <p:txBody>
-          <a:bodyPr wrap="square" lIns="73152" tIns="36576" rIns="73152" bIns="36576" rtlCol="0" anchor="t">
-            <a:noAutofit/>
+          <p:cNvPr id="4" name="Content 4"/>
+          <p:cNvSpPr>
+            <a:spLocks noGrp="1"/>
+          </p:cNvSpPr>
+          <p:nvPr>
+            <p:ph type="body" sz="quarter" idx="10"/>
+          </p:nvPr>
+        </p:nvSpPr>
+        <p:spPr>
+          <a:xfrm>
+            <a:off x="457200" y="1517904"/>
+            <a:ext cx="8229600" cy="2926080"/>
+          </a:xfrm>
+        </p:spPr>
+        <p:txBody>
+          <a:bodyPr anchor="t">
+            <a:normAutofit/>
           </a:bodyPr>
           <a:lstStyle/>
           <a:p>
             <a:pPr>
               <a:spcBef>
-                <a:spcPts val="0"/>
+                <a:spcPts val="700"/>
               </a:spcBef>
             </a:pPr>
             <a:r>
-              <a:rPr lang="en-US" sz="1600" dirty="0">
-                <a:solidFill>
-                  <a:srgbClr val="1A1B1B"/>
-                </a:solidFill>
-                <a:latin typeface="Roboto"/>
-                <a:cs typeface="Roboto"/>
-              </a:rPr>
-              <a:t>Dear AI Agent: The Servers Are On-Prem. Good Luck (Jan Egil Ring, L400)</a:t>
-            </a:r>
-          </a:p>
-        </p:txBody>
-      </p:sp>
-      <p:sp>
-        <p:nvSpPr>
-          <p:cNvPr id="7" name="Card 7"/>
-          <p:cNvSpPr/>
-          <p:nvPr/>
-        </p:nvSpPr>
-        <p:spPr>
-          <a:xfrm>
-            <a:off x="2560320" y="1853184"/>
-            <a:ext cx="1920240" cy="2164080"/>
-          </a:xfrm>
-          <a:prstGeom prst="roundRect">
-            <a:avLst>
-              <a:gd name="adj" fmla="val 6000"/>
-            </a:avLst>
-          </a:prstGeom>
-          <a:solidFill>
-            <a:srgbClr val="FFFFFF"/>
-          </a:solidFill>
-          <a:ln w="19050">
-            <a:solidFill>
-              <a:srgbClr val="193233"/>
-            </a:solidFill>
-          </a:ln>
-        </p:spPr>
-        <p:txBody>
-          <a:bodyPr rtlCol="0" anchor="ctr"/>
-          <a:lstStyle/>
-          <a:p>
-            <a:endParaRPr lang="en-US" dirty="0"/>
-          </a:p>
-        </p:txBody>
-      </p:sp>
-      <p:sp>
-        <p:nvSpPr>
-          <p:cNvPr id="8" name="Rule 8"/>
-          <p:cNvSpPr/>
-          <p:nvPr/>
-        </p:nvSpPr>
-        <p:spPr>
-          <a:xfrm>
-            <a:off x="2724912" y="2036064"/>
-            <a:ext cx="457200" cy="64008"/>
-          </a:xfrm>
-          <a:prstGeom prst="rect">
-            <a:avLst/>
-          </a:prstGeom>
-          <a:solidFill>
-            <a:srgbClr val="FDBA12"/>
-          </a:solidFill>
-          <a:ln>
-            <a:noFill/>
-          </a:ln>
-        </p:spPr>
-        <p:txBody>
-          <a:bodyPr rtlCol="0" anchor="ctr"/>
-          <a:lstStyle/>
-          <a:p>
-            <a:endParaRPr lang="en-US" dirty="0"/>
-          </a:p>
-        </p:txBody>
-      </p:sp>
-      <p:sp>
-        <p:nvSpPr>
-          <p:cNvPr id="9" name="Text 9"/>
-          <p:cNvSpPr txBox="1"/>
-          <p:nvPr/>
-        </p:nvSpPr>
-        <p:spPr>
-          <a:xfrm>
-            <a:off x="2651760" y="2173224"/>
-            <a:ext cx="1737360" cy="1752600"/>
-          </a:xfrm>
-          <a:prstGeom prst="rect">
-            <a:avLst/>
-          </a:prstGeom>
-          <a:noFill/>
-          <a:ln>
-            <a:noFill/>
-          </a:ln>
-        </p:spPr>
-        <p:txBody>
-          <a:bodyPr wrap="square" lIns="73152" tIns="36576" rIns="73152" bIns="36576" rtlCol="0" anchor="t">
-            <a:noAutofit/>
-          </a:bodyPr>
-          <a:lstStyle/>
+              <a:rPr lang="en-US" sz="1800" dirty="0"/>
+              <a:t>Breaking the Platform Barrier: AVD Hybrid on Any Hypervisor (Gregor Reimling &amp; Marcel Meurer, L300, Wed 2:40 pm, Room 5)</a:t>
+            </a:r>
+          </a:p>
           <a:p>
             <a:pPr>
               <a:spcBef>
-                <a:spcPts val="0"/>
+                <a:spcPts val="700"/>
               </a:spcBef>
             </a:pPr>
             <a:r>
-              <a:rPr lang="en-US" sz="1600" dirty="0">
-                <a:solidFill>
-                  <a:srgbClr val="1A1B1B"/>
-                </a:solidFill>
-                <a:latin typeface="Roboto"/>
-                <a:cs typeface="Roboto"/>
-              </a:rPr>
-              <a:t>Combining identity and network controls in Azure (Kristoffer Hatland, L400)</a:t>
-            </a:r>
-          </a:p>
-        </p:txBody>
-      </p:sp>
-      <p:sp>
-        <p:nvSpPr>
-          <p:cNvPr id="10" name="Card 10"/>
-          <p:cNvSpPr/>
-          <p:nvPr/>
-        </p:nvSpPr>
-        <p:spPr>
-          <a:xfrm>
-            <a:off x="4663440" y="1853184"/>
-            <a:ext cx="1920240" cy="2164080"/>
-          </a:xfrm>
-          <a:prstGeom prst="roundRect">
-            <a:avLst>
-              <a:gd name="adj" fmla="val 6000"/>
-            </a:avLst>
-          </a:prstGeom>
-          <a:solidFill>
-            <a:srgbClr val="FFFFFF"/>
-          </a:solidFill>
-          <a:ln w="19050">
-            <a:solidFill>
-              <a:srgbClr val="193233"/>
-            </a:solidFill>
-          </a:ln>
-        </p:spPr>
-        <p:txBody>
-          <a:bodyPr rtlCol="0" anchor="ctr"/>
-          <a:lstStyle/>
-          <a:p>
-            <a:endParaRPr lang="en-US" dirty="0"/>
-          </a:p>
-        </p:txBody>
-      </p:sp>
-      <p:sp>
-        <p:nvSpPr>
-          <p:cNvPr id="11" name="Rule 11"/>
-          <p:cNvSpPr/>
-          <p:nvPr/>
-        </p:nvSpPr>
-        <p:spPr>
-          <a:xfrm>
-            <a:off x="4828032" y="2036064"/>
-            <a:ext cx="457200" cy="64008"/>
-          </a:xfrm>
-          <a:prstGeom prst="rect">
-            <a:avLst/>
-          </a:prstGeom>
-          <a:solidFill>
-            <a:srgbClr val="FDBA12"/>
-          </a:solidFill>
-          <a:ln>
-            <a:noFill/>
-          </a:ln>
-        </p:spPr>
-        <p:txBody>
-          <a:bodyPr rtlCol="0" anchor="ctr"/>
-          <a:lstStyle/>
-          <a:p>
-            <a:endParaRPr lang="en-US" dirty="0"/>
-          </a:p>
-        </p:txBody>
-      </p:sp>
-      <p:sp>
-        <p:nvSpPr>
-          <p:cNvPr id="12" name="Text 12"/>
-          <p:cNvSpPr txBox="1"/>
-          <p:nvPr/>
-        </p:nvSpPr>
-        <p:spPr>
-          <a:xfrm>
-            <a:off x="4754880" y="2173224"/>
-            <a:ext cx="1737360" cy="1752600"/>
-          </a:xfrm>
-          <a:prstGeom prst="rect">
-            <a:avLst/>
-          </a:prstGeom>
-          <a:noFill/>
-          <a:ln>
-            <a:noFill/>
-          </a:ln>
-        </p:spPr>
-        <p:txBody>
-          <a:bodyPr wrap="square" lIns="73152" tIns="36576" rIns="73152" bIns="36576" rtlCol="0" anchor="t">
-            <a:noAutofit/>
-          </a:bodyPr>
-          <a:lstStyle/>
+              <a:rPr lang="en-US" sz="1800" dirty="0"/>
+              <a:t>Combining identity and network controls in Azure (Kristoffer Hatland, L400, Thu 1:00 pm, Room 3)</a:t>
+            </a:r>
+          </a:p>
           <a:p>
             <a:pPr>
               <a:spcBef>
-                <a:spcPts val="0"/>
+                <a:spcPts val="700"/>
               </a:spcBef>
             </a:pPr>
             <a:r>
-              <a:rPr lang="en-US" sz="1600" dirty="0">
-                <a:solidFill>
-                  <a:srgbClr val="1A1B1B"/>
-                </a:solidFill>
-                <a:latin typeface="Roboto"/>
-                <a:cs typeface="Roboto"/>
-              </a:rPr>
-              <a:t>10 security settings you must configure in Windows 11 (Nicklas Ahlberg, L300)</a:t>
-            </a:r>
-          </a:p>
-        </p:txBody>
-      </p:sp>
-      <p:sp>
-        <p:nvSpPr>
-          <p:cNvPr id="13" name="Card 13"/>
-          <p:cNvSpPr/>
-          <p:nvPr/>
-        </p:nvSpPr>
-        <p:spPr>
-          <a:xfrm>
-            <a:off x="6766560" y="1853184"/>
-            <a:ext cx="1920240" cy="2164080"/>
-          </a:xfrm>
-          <a:prstGeom prst="roundRect">
-            <a:avLst>
-              <a:gd name="adj" fmla="val 6000"/>
-            </a:avLst>
-          </a:prstGeom>
-          <a:solidFill>
-            <a:srgbClr val="FFFFFF"/>
-          </a:solidFill>
-          <a:ln w="19050">
-            <a:solidFill>
-              <a:srgbClr val="193233"/>
-            </a:solidFill>
-          </a:ln>
-        </p:spPr>
-        <p:txBody>
-          <a:bodyPr rtlCol="0" anchor="ctr"/>
-          <a:lstStyle/>
-          <a:p>
-            <a:endParaRPr lang="en-US" dirty="0"/>
-          </a:p>
-        </p:txBody>
-      </p:sp>
-      <p:sp>
-        <p:nvSpPr>
-          <p:cNvPr id="14" name="Rule 14"/>
-          <p:cNvSpPr/>
-          <p:nvPr/>
-        </p:nvSpPr>
-        <p:spPr>
-          <a:xfrm>
-            <a:off x="6931152" y="2036064"/>
-            <a:ext cx="457200" cy="64008"/>
-          </a:xfrm>
-          <a:prstGeom prst="rect">
-            <a:avLst/>
-          </a:prstGeom>
-          <a:solidFill>
-            <a:srgbClr val="FDBA12"/>
-          </a:solidFill>
-          <a:ln>
-            <a:noFill/>
-          </a:ln>
-        </p:spPr>
-        <p:txBody>
-          <a:bodyPr rtlCol="0" anchor="ctr"/>
-          <a:lstStyle/>
-          <a:p>
-            <a:endParaRPr lang="en-US" dirty="0"/>
-          </a:p>
-        </p:txBody>
-      </p:sp>
-      <p:sp>
-        <p:nvSpPr>
-          <p:cNvPr id="15" name="Text 15"/>
-          <p:cNvSpPr txBox="1"/>
-          <p:nvPr/>
-        </p:nvSpPr>
-        <p:spPr>
-          <a:xfrm>
-            <a:off x="6858000" y="2173224"/>
-            <a:ext cx="1737360" cy="1752600"/>
-          </a:xfrm>
-          <a:prstGeom prst="rect">
-            <a:avLst/>
-          </a:prstGeom>
-          <a:noFill/>
-          <a:ln>
-            <a:noFill/>
-          </a:ln>
-        </p:spPr>
-        <p:txBody>
-          <a:bodyPr wrap="square" lIns="73152" tIns="36576" rIns="73152" bIns="36576" rtlCol="0" anchor="t">
-            <a:noAutofit/>
-          </a:bodyPr>
-          <a:lstStyle/>
+              <a:rPr lang="en-US" sz="1800" dirty="0"/>
+              <a:t>10 security settings you must configure in Windows 11 (Nicklas Ahlberg, L300, Thu 11:10 am, Room 5)</a:t>
+            </a:r>
+          </a:p>
           <a:p>
             <a:pPr>
               <a:spcBef>
-                <a:spcPts val="0"/>
+                <a:spcPts val="700"/>
               </a:spcBef>
             </a:pPr>
             <a:r>
-              <a:rPr lang="en-US" sz="1600" dirty="0">
-                <a:solidFill>
-                  <a:srgbClr val="1A1B1B"/>
-                </a:solidFill>
-                <a:latin typeface="Roboto"/>
-                <a:cs typeface="Roboto"/>
-              </a:rPr>
-              <a:t>Check the NIC agenda for room and time.</a:t>
+              <a:rPr lang="en-US" sz="1800" dirty="0"/>
+              <a:t>Times are Oslo time. Rooms can change: check the NIC agenda.</a:t>
             </a:r>
           </a:p>
         </p:txBody>
       </p:sp>
       <p:cxnSp>
         <p:nvCxnSpPr>
-          <p:cNvPr id="16" name="Line 16"/>
+          <p:cNvPr id="5" name="Line 5"/>
           <p:cNvCxnSpPr/>
           <p:nvPr/>
         </p:nvCxnSpPr>
@@ -19178,7 +18825,7 @@
       </p:cxnSp>
       <p:sp>
         <p:nvSpPr>
-          <p:cNvPr id="17" name="Node 17"/>
+          <p:cNvPr id="6" name="Node 6"/>
           <p:cNvSpPr/>
           <p:nvPr/>
         </p:nvSpPr>
@@ -19207,7 +18854,7 @@
       </p:sp>
       <p:sp>
         <p:nvSpPr>
-          <p:cNvPr id="18" name="Text 18"/>
+          <p:cNvPr id="7" name="Text 7"/>
           <p:cNvSpPr txBox="1"/>
           <p:nvPr/>
         </p:nvSpPr>
@@ -19246,7 +18893,7 @@
       </p:sp>
       <p:sp>
         <p:nvSpPr>
-          <p:cNvPr id="19" name="Node 19"/>
+          <p:cNvPr id="8" name="Node 8"/>
           <p:cNvSpPr/>
           <p:nvPr/>
         </p:nvSpPr>
@@ -19275,7 +18922,7 @@
       </p:sp>
       <p:sp>
         <p:nvSpPr>
-          <p:cNvPr id="20" name="Text 20"/>
+          <p:cNvPr id="9" name="Text 9"/>
           <p:cNvSpPr txBox="1"/>
           <p:nvPr/>
         </p:nvSpPr>
@@ -19314,7 +18961,7 @@
       </p:sp>
       <p:sp>
         <p:nvSpPr>
-          <p:cNvPr id="21" name="Node 21"/>
+          <p:cNvPr id="10" name="Node 10"/>
           <p:cNvSpPr/>
           <p:nvPr/>
         </p:nvSpPr>
@@ -19343,7 +18990,7 @@
       </p:sp>
       <p:sp>
         <p:nvSpPr>
-          <p:cNvPr id="22" name="Text 22"/>
+          <p:cNvPr id="11" name="Text 11"/>
           <p:cNvSpPr txBox="1"/>
           <p:nvPr/>
         </p:nvSpPr>
@@ -19382,7 +19029,7 @@
       </p:sp>
       <p:sp>
         <p:nvSpPr>
-          <p:cNvPr id="23" name="Text 23"/>
+          <p:cNvPr id="12" name="Text 12"/>
           <p:cNvSpPr txBox="1"/>
           <p:nvPr/>
         </p:nvSpPr>

</xml_diff>

<commit_message>
docs: regenerate deck after Hybrid section re-cut
</commit_message>
<xml_diff>
--- a/presentation/AVD_Anywhere_NIC2026.pptx
+++ b/presentation/AVD_Anywhere_NIC2026.pptx
@@ -8166,7 +8166,7 @@
               </a:spcBef>
             </a:pPr>
             <a:r>
-              <a:rPr lang="en-US" sz="1850" dirty="0"/>
+              <a:rPr lang="en-US" sz="1750" dirty="0"/>
               <a:t>1. Create a Windows VM with your tools</a:t>
             </a:r>
           </a:p>
@@ -8177,7 +8177,7 @@
               </a:spcBef>
             </a:pPr>
             <a:r>
-              <a:rPr lang="en-US" sz="1850" dirty="0"/>
+              <a:rPr lang="en-US" sz="1750" dirty="0"/>
               <a:t>2. Install the Arc agent in the guest</a:t>
             </a:r>
           </a:p>
@@ -8188,7 +8188,7 @@
               </a:spcBef>
             </a:pPr>
             <a:r>
-              <a:rPr lang="en-US" sz="1850" dirty="0"/>
+              <a:rPr lang="en-US" sz="1750" dirty="0"/>
               <a:t>3. Add the AVD Hybrid extension with a registration token</a:t>
             </a:r>
           </a:p>
@@ -8199,7 +8199,7 @@
               </a:spcBef>
             </a:pPr>
             <a:r>
-              <a:rPr lang="en-US" sz="1850" dirty="0"/>
+              <a:rPr lang="en-US" sz="1750" dirty="0"/>
               <a:t>4. Host Available (documented expectation: up to 15 minutes; set a timeout)</a:t>
             </a:r>
           </a:p>
@@ -8210,7 +8210,7 @@
               </a:spcBef>
             </a:pPr>
             <a:r>
-              <a:rPr lang="en-US" sz="1850" dirty="0"/>
+              <a:rPr lang="en-US" sz="1750" dirty="0"/>
               <a:t>No hypervisor integration; everything happens inside the guest</a:t>
             </a:r>
           </a:p>
@@ -8221,8 +8221,8 @@
               </a:spcBef>
             </a:pPr>
             <a:r>
-              <a:rPr lang="en-US" sz="1850" dirty="0"/>
-              <a:t>You own the lifecycle</a:t>
+              <a:rPr lang="en-US" sz="1750" dirty="0"/>
+              <a:t>AVD never powers, scales, replaces or patches this VM: you own the lifecycle</a:t>
             </a:r>
           </a:p>
         </p:txBody>
@@ -8623,321 +8623,84 @@
                 <a:latin typeface="Roboto"/>
                 <a:cs typeface="Roboto"/>
               </a:rPr>
-              <a:t>What Hybrid requires and does not offer.</a:t>
-            </a:r>
-          </a:p>
-        </p:txBody>
-      </p:sp>
-      <p:sp>
-        <p:nvSpPr>
-          <p:cNvPr id="5" name="Card 5"/>
-          <p:cNvSpPr/>
-          <p:nvPr/>
-        </p:nvSpPr>
-        <p:spPr>
-          <a:xfrm>
-            <a:off x="457200" y="2097024"/>
-            <a:ext cx="2621280" cy="1676400"/>
-          </a:xfrm>
-          <a:prstGeom prst="roundRect">
-            <a:avLst>
-              <a:gd name="adj" fmla="val 6000"/>
-            </a:avLst>
-          </a:prstGeom>
-          <a:solidFill>
-            <a:srgbClr val="262929"/>
-          </a:solidFill>
-          <a:ln w="19050">
-            <a:solidFill>
-              <a:srgbClr val="98F8FE"/>
-            </a:solidFill>
-          </a:ln>
-        </p:spPr>
-        <p:txBody>
-          <a:bodyPr rtlCol="0" anchor="ctr"/>
-          <a:lstStyle/>
-          <a:p>
-            <a:endParaRPr lang="en-US" dirty="0"/>
-          </a:p>
-        </p:txBody>
-      </p:sp>
-      <p:sp>
-        <p:nvSpPr>
-          <p:cNvPr id="6" name="Rule 6"/>
-          <p:cNvSpPr/>
-          <p:nvPr/>
-        </p:nvSpPr>
-        <p:spPr>
-          <a:xfrm>
-            <a:off x="621792" y="2279904"/>
-            <a:ext cx="457200" cy="64008"/>
-          </a:xfrm>
-          <a:prstGeom prst="rect">
-            <a:avLst/>
-          </a:prstGeom>
-          <a:solidFill>
-            <a:srgbClr val="FDBA12"/>
-          </a:solidFill>
-          <a:ln>
-            <a:noFill/>
-          </a:ln>
-        </p:spPr>
-        <p:txBody>
-          <a:bodyPr rtlCol="0" anchor="ctr"/>
-          <a:lstStyle/>
-          <a:p>
-            <a:endParaRPr lang="en-US" dirty="0"/>
-          </a:p>
-        </p:txBody>
-      </p:sp>
-      <p:sp>
-        <p:nvSpPr>
-          <p:cNvPr id="7" name="Text 7"/>
-          <p:cNvSpPr txBox="1"/>
-          <p:nvPr/>
-        </p:nvSpPr>
-        <p:spPr>
-          <a:xfrm>
-            <a:off x="548640" y="2417064"/>
-            <a:ext cx="2438400" cy="1264920"/>
-          </a:xfrm>
-          <a:prstGeom prst="rect">
-            <a:avLst/>
-          </a:prstGeom>
-          <a:noFill/>
-          <a:ln>
-            <a:noFill/>
-          </a:ln>
-        </p:spPr>
-        <p:txBody>
-          <a:bodyPr wrap="square" lIns="73152" tIns="36576" rIns="73152" bIns="36576" rtlCol="0" anchor="t">
-            <a:noAutofit/>
+              <a:t>What Hybrid requires of the Arc machine and does not offer.</a:t>
+            </a:r>
+          </a:p>
+        </p:txBody>
+      </p:sp>
+      <p:sp>
+        <p:nvSpPr>
+          <p:cNvPr id="5" name="Content 5"/>
+          <p:cNvSpPr>
+            <a:spLocks noGrp="1"/>
+          </p:cNvSpPr>
+          <p:nvPr>
+            <p:ph type="body" sz="quarter" idx="10"/>
+          </p:nvPr>
+        </p:nvSpPr>
+        <p:spPr>
+          <a:xfrm>
+            <a:off x="457200" y="1517904"/>
+            <a:ext cx="8229600" cy="2926080"/>
+          </a:xfrm>
+        </p:spPr>
+        <p:txBody>
+          <a:bodyPr anchor="t">
+            <a:normAutofit/>
           </a:bodyPr>
           <a:lstStyle/>
           <a:p>
             <a:pPr>
               <a:spcBef>
-                <a:spcPts val="0"/>
+                <a:spcPts val="700"/>
               </a:spcBef>
             </a:pPr>
             <a:r>
-              <a:rPr lang="en-US" sz="1600" dirty="0">
-                <a:solidFill>
-                  <a:srgbClr val="98F8FE"/>
-                </a:solidFill>
-                <a:latin typeface="Roboto"/>
-                <a:cs typeface="Roboto"/>
-              </a:rPr>
+              <a:rPr lang="en-US" sz="1600" dirty="0"/>
               <a:t>Win11 Enterprise single-session or Windows Server; no multi-session</a:t>
             </a:r>
           </a:p>
-        </p:txBody>
-      </p:sp>
-      <p:sp>
-        <p:nvSpPr>
-          <p:cNvPr id="8" name="Card 8"/>
-          <p:cNvSpPr/>
-          <p:nvPr/>
-        </p:nvSpPr>
-        <p:spPr>
-          <a:xfrm>
-            <a:off x="3261360" y="2097024"/>
-            <a:ext cx="2621280" cy="1676400"/>
-          </a:xfrm>
-          <a:prstGeom prst="roundRect">
-            <a:avLst>
-              <a:gd name="adj" fmla="val 6000"/>
-            </a:avLst>
-          </a:prstGeom>
-          <a:solidFill>
-            <a:srgbClr val="262929"/>
-          </a:solidFill>
-          <a:ln w="19050">
-            <a:solidFill>
-              <a:srgbClr val="98F8FE"/>
-            </a:solidFill>
-          </a:ln>
-        </p:spPr>
-        <p:txBody>
-          <a:bodyPr rtlCol="0" anchor="ctr"/>
-          <a:lstStyle/>
-          <a:p>
-            <a:endParaRPr lang="en-US" dirty="0"/>
-          </a:p>
-        </p:txBody>
-      </p:sp>
-      <p:sp>
-        <p:nvSpPr>
-          <p:cNvPr id="9" name="Rule 9"/>
-          <p:cNvSpPr/>
-          <p:nvPr/>
-        </p:nvSpPr>
-        <p:spPr>
-          <a:xfrm>
-            <a:off x="3425952" y="2279904"/>
-            <a:ext cx="457200" cy="64008"/>
-          </a:xfrm>
-          <a:prstGeom prst="rect">
-            <a:avLst/>
-          </a:prstGeom>
-          <a:solidFill>
-            <a:srgbClr val="FDBA12"/>
-          </a:solidFill>
-          <a:ln>
-            <a:noFill/>
-          </a:ln>
-        </p:spPr>
-        <p:txBody>
-          <a:bodyPr rtlCol="0" anchor="ctr"/>
-          <a:lstStyle/>
-          <a:p>
-            <a:endParaRPr lang="en-US" dirty="0"/>
-          </a:p>
-        </p:txBody>
-      </p:sp>
-      <p:sp>
-        <p:nvSpPr>
-          <p:cNvPr id="10" name="Text 10"/>
-          <p:cNvSpPr txBox="1"/>
-          <p:nvPr/>
-        </p:nvSpPr>
-        <p:spPr>
-          <a:xfrm>
-            <a:off x="3352800" y="2417064"/>
-            <a:ext cx="2438400" cy="1264920"/>
-          </a:xfrm>
-          <a:prstGeom prst="rect">
-            <a:avLst/>
-          </a:prstGeom>
-          <a:noFill/>
-          <a:ln>
-            <a:noFill/>
-          </a:ln>
-        </p:spPr>
-        <p:txBody>
-          <a:bodyPr wrap="square" lIns="73152" tIns="36576" rIns="73152" bIns="36576" rtlCol="0" anchor="t">
-            <a:noAutofit/>
-          </a:bodyPr>
-          <a:lstStyle/>
           <a:p>
             <a:pPr>
               <a:spcBef>
-                <a:spcPts val="0"/>
+                <a:spcPts val="700"/>
               </a:spcBef>
             </a:pPr>
             <a:r>
-              <a:rPr lang="en-US" sz="1600" dirty="0">
-                <a:solidFill>
-                  <a:srgbClr val="98F8FE"/>
-                </a:solidFill>
-                <a:latin typeface="Roboto"/>
-                <a:cs typeface="Roboto"/>
-              </a:rPr>
-              <a:t>Server needs AD; Win11 can be Entra-only</a:t>
-            </a:r>
-          </a:p>
-        </p:txBody>
-      </p:sp>
-      <p:sp>
-        <p:nvSpPr>
-          <p:cNvPr id="11" name="Card 11"/>
-          <p:cNvSpPr/>
-          <p:nvPr/>
-        </p:nvSpPr>
-        <p:spPr>
-          <a:xfrm>
-            <a:off x="6065520" y="2097024"/>
-            <a:ext cx="2621280" cy="1676400"/>
-          </a:xfrm>
-          <a:prstGeom prst="roundRect">
-            <a:avLst>
-              <a:gd name="adj" fmla="val 6000"/>
-            </a:avLst>
-          </a:prstGeom>
-          <a:solidFill>
-            <a:srgbClr val="262929"/>
-          </a:solidFill>
-          <a:ln w="19050">
-            <a:solidFill>
-              <a:srgbClr val="98F8FE"/>
-            </a:solidFill>
-          </a:ln>
-        </p:spPr>
-        <p:txBody>
-          <a:bodyPr rtlCol="0" anchor="ctr"/>
-          <a:lstStyle/>
-          <a:p>
-            <a:endParaRPr lang="en-US" dirty="0"/>
-          </a:p>
-        </p:txBody>
-      </p:sp>
-      <p:sp>
-        <p:nvSpPr>
-          <p:cNvPr id="12" name="Rule 12"/>
-          <p:cNvSpPr/>
-          <p:nvPr/>
-        </p:nvSpPr>
-        <p:spPr>
-          <a:xfrm>
-            <a:off x="6230112" y="2279904"/>
-            <a:ext cx="457200" cy="64008"/>
-          </a:xfrm>
-          <a:prstGeom prst="rect">
-            <a:avLst/>
-          </a:prstGeom>
-          <a:solidFill>
-            <a:srgbClr val="FDBA12"/>
-          </a:solidFill>
-          <a:ln>
-            <a:noFill/>
-          </a:ln>
-        </p:spPr>
-        <p:txBody>
-          <a:bodyPr rtlCol="0" anchor="ctr"/>
-          <a:lstStyle/>
-          <a:p>
-            <a:endParaRPr lang="en-US" dirty="0"/>
-          </a:p>
-        </p:txBody>
-      </p:sp>
-      <p:sp>
-        <p:nvSpPr>
-          <p:cNvPr id="13" name="Text 13"/>
-          <p:cNvSpPr txBox="1"/>
-          <p:nvPr/>
-        </p:nvSpPr>
-        <p:spPr>
-          <a:xfrm>
-            <a:off x="6156960" y="2417064"/>
-            <a:ext cx="2438400" cy="1264920"/>
-          </a:xfrm>
-          <a:prstGeom prst="rect">
-            <a:avLst/>
-          </a:prstGeom>
-          <a:noFill/>
-          <a:ln>
-            <a:noFill/>
-          </a:ln>
-        </p:spPr>
-        <p:txBody>
-          <a:bodyPr wrap="square" lIns="73152" tIns="36576" rIns="73152" bIns="36576" rtlCol="0" anchor="t">
-            <a:noAutofit/>
-          </a:bodyPr>
-          <a:lstStyle/>
+              <a:rPr lang="en-US" sz="1600" dirty="0"/>
+              <a:t>Server needs AD; Win11 can be Entra-only, joined at build; VM User Login on the Arc machine scope</a:t>
+            </a:r>
+          </a:p>
           <a:p>
             <a:pPr>
               <a:spcBef>
-                <a:spcPts val="0"/>
+                <a:spcPts val="700"/>
               </a:spcBef>
             </a:pPr>
             <a:r>
-              <a:rPr lang="en-US" sz="1600" dirty="0">
-                <a:solidFill>
-                  <a:srgbClr val="98F8FE"/>
-                </a:solidFill>
-                <a:latin typeface="Roboto"/>
-                <a:cs typeface="Roboto"/>
-              </a:rPr>
+              <a:rPr lang="en-US" sz="1600" dirty="0"/>
+              <a:t>Standard pool; its managed identity has Reader on the Arc machines' resource group (here: inside the AVD landing zone)</a:t>
+            </a:r>
+          </a:p>
+          <a:p>
+            <a:pPr>
+              <a:spcBef>
+                <a:spcPts val="700"/>
+              </a:spcBef>
+            </a:pPr>
+            <a:r>
+              <a:rPr lang="en-US" sz="1600" dirty="0"/>
+              <a:t>Arc onboarding by service principal, secret in memory, rotated; outbound 443 to AVD and Arc endpoints; RDP Shortpath</a:t>
+            </a:r>
+          </a:p>
+          <a:p>
+            <a:pPr>
+              <a:spcBef>
+                <a:spcPts val="700"/>
+              </a:spcBef>
+            </a:pPr>
+            <a:r>
+              <a:rPr lang="en-US" sz="1600" dirty="0"/>
               <a:t>No autoscale, power management, Start VM on Connect, Session Host Configuration</a:t>
             </a:r>
           </a:p>
@@ -8945,7 +8708,7 @@
       </p:sp>
       <p:cxnSp>
         <p:nvCxnSpPr>
-          <p:cNvPr id="14" name="Line 14"/>
+          <p:cNvPr id="6" name="Line 6"/>
           <p:cNvCxnSpPr/>
           <p:nvPr/>
         </p:nvCxnSpPr>
@@ -8966,7 +8729,7 @@
       </p:cxnSp>
       <p:sp>
         <p:nvSpPr>
-          <p:cNvPr id="15" name="Node 15"/>
+          <p:cNvPr id="7" name="Node 7"/>
           <p:cNvSpPr/>
           <p:nvPr/>
         </p:nvSpPr>
@@ -8995,7 +8758,7 @@
       </p:sp>
       <p:sp>
         <p:nvSpPr>
-          <p:cNvPr id="16" name="Text 16"/>
+          <p:cNvPr id="8" name="Text 8"/>
           <p:cNvSpPr txBox="1"/>
           <p:nvPr/>
         </p:nvSpPr>
@@ -9034,7 +8797,7 @@
       </p:sp>
       <p:sp>
         <p:nvSpPr>
-          <p:cNvPr id="17" name="Node 17"/>
+          <p:cNvPr id="9" name="Node 9"/>
           <p:cNvSpPr/>
           <p:nvPr/>
         </p:nvSpPr>
@@ -9063,7 +8826,7 @@
       </p:sp>
       <p:sp>
         <p:nvSpPr>
-          <p:cNvPr id="18" name="Text 18"/>
+          <p:cNvPr id="10" name="Text 10"/>
           <p:cNvSpPr txBox="1"/>
           <p:nvPr/>
         </p:nvSpPr>
@@ -9102,7 +8865,7 @@
       </p:sp>
       <p:sp>
         <p:nvSpPr>
-          <p:cNvPr id="19" name="Node 19"/>
+          <p:cNvPr id="11" name="Node 11"/>
           <p:cNvSpPr/>
           <p:nvPr/>
         </p:nvSpPr>
@@ -9131,7 +8894,7 @@
       </p:sp>
       <p:sp>
         <p:nvSpPr>
-          <p:cNvPr id="20" name="Text 20"/>
+          <p:cNvPr id="12" name="Text 12"/>
           <p:cNvSpPr txBox="1"/>
           <p:nvPr/>
         </p:nvSpPr>
@@ -9170,7 +8933,7 @@
       </p:sp>
       <p:sp>
         <p:nvSpPr>
-          <p:cNvPr id="21" name="Text 21"/>
+          <p:cNvPr id="13" name="Text 13"/>
           <p:cNvSpPr txBox="1"/>
           <p:nvPr/>
         </p:nvSpPr>
@@ -10714,14 +10477,14 @@
           <a:p>
             <a:pPr algn="ctr"/>
             <a:r>
-              <a:rPr lang="en-US" sz="1300" i="1" dirty="0">
+              <a:rPr lang="en-US" sz="1000" i="1" dirty="0">
                 <a:solidFill>
                   <a:srgbClr val="193233"/>
                 </a:solidFill>
                 <a:latin typeface="Roboto"/>
                 <a:cs typeface="Roboto"/>
               </a:rPr>
-              <a:t>Packer plus platform-native tools; patching is an owner question.</a:t>
+              <a:t>Packer plus platform-native tools, running the same customisation scripts AIB runs; Entra join and the FSLogix profile baked in...</a:t>
             </a:r>
           </a:p>
         </p:txBody>
@@ -10754,8 +10517,8 @@
               </a:spcBef>
             </a:pPr>
             <a:r>
-              <a:rPr lang="en-US" sz="2200" dirty="0"/>
-              <a:t>hyperv-iso, vsphere-iso, Nutanix plugin</a:t>
+              <a:rPr lang="en-US" sz="1550" dirty="0"/>
+              <a:t>hyperv-iso (tested), vsphere-iso and Nutanix plugin (reference): one build, the AIB customisation scripts reused</a:t>
             </a:r>
           </a:p>
           <a:p>
@@ -10765,8 +10528,8 @@
               </a:spcBef>
             </a:pPr>
             <a:r>
-              <a:rPr lang="en-US" sz="2200" dirty="0"/>
-              <a:t>Entra join in the build</a:t>
+              <a:rPr lang="en-US" sz="1550" dirty="0"/>
+              <a:t>Entra join and the FSLogix settings profile in the build; SSO back to Entra</a:t>
             </a:r>
           </a:p>
           <a:p>
@@ -10776,8 +10539,8 @@
               </a:spcBef>
             </a:pPr>
             <a:r>
-              <a:rPr lang="en-US" sz="2200" dirty="0"/>
-              <a:t>Windows 11 patching: Intune or Windows Update for Business</a:t>
+              <a:rPr lang="en-US" sz="1550" dirty="0"/>
+              <a:t>Outbound only through the firewall allow-list; RDP Shortpath; GPU per hypervisor, AVD neither adds nor blocks</a:t>
             </a:r>
           </a:p>
           <a:p>
@@ -10787,8 +10550,8 @@
               </a:spcBef>
             </a:pPr>
             <a:r>
-              <a:rPr lang="en-US" sz="2200" dirty="0"/>
-              <a:t>Outbound only through the firewall allow-list; RDP Shortpath</a:t>
+              <a:rPr lang="en-US" sz="1550" dirty="0"/>
+              <a:t>Windows 11 patching: Intune or Windows Update for Business; Azure Update Manager does not cover Windows 11</a:t>
             </a:r>
           </a:p>
           <a:p>
@@ -10798,8 +10561,8 @@
               </a:spcBef>
             </a:pPr>
             <a:r>
-              <a:rPr lang="en-US" sz="2200" dirty="0"/>
-              <a:t>Azure Update Manager does not cover Windows 11</a:t>
+              <a:rPr lang="en-US" sz="1550" dirty="0"/>
+              <a:t>Arc here: AMA + DCR, AVD Insights, inventory. Update Manager, Policy, Defender, Arc licensing: Room 5, 14:40</a:t>
             </a:r>
           </a:p>
         </p:txBody>
@@ -18690,8 +18453,8 @@
           <a:p>
             <a:pPr/>
             <a:r>
-              <a:rPr lang="en-US" sz="2500" dirty="0"/>
-              <a:t>You may also like: more sagas worth your time</a:t>
+              <a:rPr lang="en-US" sz="2600" dirty="0"/>
+              <a:t>Next door at 14:40, and you may also like</a:t>
             </a:r>
           </a:p>
         </p:txBody>
@@ -18723,14 +18486,14 @@
           <a:p>
             <a:pPr algn="ctr"/>
             <a:r>
-              <a:rPr lang="en-US" sz="1300" i="1" dirty="0">
+              <a:rPr lang="en-US" sz="1000" i="1" dirty="0">
                 <a:solidFill>
                   <a:srgbClr val="193233"/>
                 </a:solidFill>
                 <a:latin typeface="Roboto"/>
                 <a:cs typeface="Roboto"/>
               </a:rPr>
-              <a:t>Three other NIC 2026 sessions that complement this one.</a:t>
+              <a:t>The first card is a hand-off, not a recommendation: the Arc side of AVD Hybrid continues in Room 5 twenty minutes from now.</a:t>
             </a:r>
           </a:p>
         </p:txBody>
@@ -18763,8 +18526,8 @@
               </a:spcBef>
             </a:pPr>
             <a:r>
-              <a:rPr lang="en-US" sz="1800" dirty="0"/>
-              <a:t>Breaking the Platform Barrier: AVD Hybrid on Any Hypervisor (Gregor Reimling &amp; Marcel Meurer, L300, Wed 2:40 pm, Room 5)</a:t>
+              <a:rPr lang="en-US" sz="1600" dirty="0"/>
+              <a:t>Hand-off: Breaking the Platform Barrier: AVD Hybrid on Any Hypervisor (Gregor Reimling &amp; Marcel Meurer, L300, Wed 2:40 pm, Room 5). We built the hosts, the identity and the profile; they take Arc design before onboarding, how the Arc and AVD agents work together, and day-2 with Update Manager, Policy, Defender and licensing</a:t>
             </a:r>
           </a:p>
           <a:p>
@@ -18774,7 +18537,7 @@
               </a:spcBef>
             </a:pPr>
             <a:r>
-              <a:rPr lang="en-US" sz="1800" dirty="0"/>
+              <a:rPr lang="en-US" sz="1600" dirty="0"/>
               <a:t>Combining identity and network controls in Azure (Kristoffer Hatland, L400, Thu 1:00 pm, Room 3)</a:t>
             </a:r>
           </a:p>
@@ -18785,7 +18548,7 @@
               </a:spcBef>
             </a:pPr>
             <a:r>
-              <a:rPr lang="en-US" sz="1800" dirty="0"/>
+              <a:rPr lang="en-US" sz="1600" dirty="0"/>
               <a:t>10 security settings you must configure in Windows 11 (Nicklas Ahlberg, L300, Thu 11:10 am, Room 5)</a:t>
             </a:r>
           </a:p>
@@ -18796,7 +18559,7 @@
               </a:spcBef>
             </a:pPr>
             <a:r>
-              <a:rPr lang="en-US" sz="1800" dirty="0"/>
+              <a:rPr lang="en-US" sz="1600" dirty="0"/>
               <a:t>Times are Oslo time. Rooms can change: check the NIC agenda.</a:t>
             </a:r>
           </a:p>

</xml_diff>